<commit_message>
add revamped Lecture 3
</commit_message>
<xml_diff>
--- a/Lectures/Week03/Lecture03.pptx
+++ b/Lectures/Week03/Lecture03.pptx
@@ -5,10 +5,10 @@
     <p:sldMasterId id="2147483648" r:id="rId1"/>
   </p:sldMasterIdLst>
   <p:notesMasterIdLst>
-    <p:notesMasterId r:id="rId27"/>
+    <p:notesMasterId r:id="rId28"/>
   </p:notesMasterIdLst>
   <p:handoutMasterIdLst>
-    <p:handoutMasterId r:id="rId28"/>
+    <p:handoutMasterId r:id="rId29"/>
   </p:handoutMasterIdLst>
   <p:sldIdLst>
     <p:sldId id="256" r:id="rId2"/>
@@ -35,7 +35,8 @@
     <p:sldId id="1050" r:id="rId23"/>
     <p:sldId id="1051" r:id="rId24"/>
     <p:sldId id="1052" r:id="rId25"/>
-    <p:sldId id="1042" r:id="rId26"/>
+    <p:sldId id="1056" r:id="rId26"/>
+    <p:sldId id="1042" r:id="rId27"/>
   </p:sldIdLst>
   <p:sldSz cx="9144000" cy="6858000" type="letter"/>
   <p:notesSz cx="9601200" cy="7315200"/>
@@ -3795,8 +3796,8 @@
           <a:chExt cx="0" cy="0"/>
         </a:xfrm>
       </p:grpSpPr>
-      <mc:AlternateContent xmlns:mc="http://schemas.openxmlformats.org/markup-compatibility/2006">
-        <mc:Choice xmlns:a14="http://schemas.microsoft.com/office/drawing/2010/main" Requires="a14">
+      <mc:AlternateContent xmlns:mc="http://schemas.openxmlformats.org/markup-compatibility/2006" xmlns:a14="http://schemas.microsoft.com/office/drawing/2010/main">
+        <mc:Choice Requires="a14">
           <p:sp>
             <p:nvSpPr>
               <p:cNvPr id="4" name="Content Placeholder 3">
@@ -4063,7 +4064,7 @@
             </p:txBody>
           </p:sp>
         </mc:Choice>
-        <mc:Fallback>
+        <mc:Fallback xmlns="">
           <p:sp>
             <p:nvSpPr>
               <p:cNvPr id="4" name="Content Placeholder 3">
@@ -4953,7 +4954,7 @@
                                         <p:tgtEl>
                                           <p:spTgt spid="4">
                                             <p:txEl>
-                                              <p:pRg st="0" end="0"/>
+                                              <p:pRg st="3" end="3"/>
                                             </p:txEl>
                                           </p:spTgt>
                                         </p:tgtEl>
@@ -4971,7 +4972,7 @@
                                         <p:tgtEl>
                                           <p:spTgt spid="4">
                                             <p:txEl>
-                                              <p:pRg st="0" end="0"/>
+                                              <p:pRg st="3" end="3"/>
                                             </p:txEl>
                                           </p:spTgt>
                                         </p:tgtEl>
@@ -5014,7 +5015,7 @@
                                         <p:tgtEl>
                                           <p:spTgt spid="4">
                                             <p:txEl>
-                                              <p:pRg st="1" end="1"/>
+                                              <p:pRg st="5" end="5"/>
                                             </p:txEl>
                                           </p:spTgt>
                                         </p:tgtEl>
@@ -5029,128 +5030,6 @@
                                     <p:animEffect transition="in" filter="fade">
                                       <p:cBhvr>
                                         <p:cTn id="12" dur="500"/>
-                                        <p:tgtEl>
-                                          <p:spTgt spid="4">
-                                            <p:txEl>
-                                              <p:pRg st="1" end="1"/>
-                                            </p:txEl>
-                                          </p:spTgt>
-                                        </p:tgtEl>
-                                      </p:cBhvr>
-                                    </p:animEffect>
-                                  </p:childTnLst>
-                                </p:cTn>
-                              </p:par>
-                            </p:childTnLst>
-                          </p:cTn>
-                        </p:par>
-                      </p:childTnLst>
-                    </p:cTn>
-                  </p:par>
-                  <p:par>
-                    <p:cTn id="13" fill="hold">
-                      <p:stCondLst>
-                        <p:cond delay="indefinite"/>
-                      </p:stCondLst>
-                      <p:childTnLst>
-                        <p:par>
-                          <p:cTn id="14" fill="hold">
-                            <p:stCondLst>
-                              <p:cond delay="0"/>
-                            </p:stCondLst>
-                            <p:childTnLst>
-                              <p:par>
-                                <p:cTn id="15" presetID="10" presetClass="entr" presetSubtype="0" fill="hold" nodeType="clickEffect">
-                                  <p:stCondLst>
-                                    <p:cond delay="0"/>
-                                  </p:stCondLst>
-                                  <p:childTnLst>
-                                    <p:set>
-                                      <p:cBhvr>
-                                        <p:cTn id="16" dur="1" fill="hold">
-                                          <p:stCondLst>
-                                            <p:cond delay="0"/>
-                                          </p:stCondLst>
-                                        </p:cTn>
-                                        <p:tgtEl>
-                                          <p:spTgt spid="4">
-                                            <p:txEl>
-                                              <p:pRg st="3" end="3"/>
-                                            </p:txEl>
-                                          </p:spTgt>
-                                        </p:tgtEl>
-                                        <p:attrNameLst>
-                                          <p:attrName>style.visibility</p:attrName>
-                                        </p:attrNameLst>
-                                      </p:cBhvr>
-                                      <p:to>
-                                        <p:strVal val="visible"/>
-                                      </p:to>
-                                    </p:set>
-                                    <p:animEffect transition="in" filter="fade">
-                                      <p:cBhvr>
-                                        <p:cTn id="17" dur="500"/>
-                                        <p:tgtEl>
-                                          <p:spTgt spid="4">
-                                            <p:txEl>
-                                              <p:pRg st="3" end="3"/>
-                                            </p:txEl>
-                                          </p:spTgt>
-                                        </p:tgtEl>
-                                      </p:cBhvr>
-                                    </p:animEffect>
-                                  </p:childTnLst>
-                                </p:cTn>
-                              </p:par>
-                            </p:childTnLst>
-                          </p:cTn>
-                        </p:par>
-                      </p:childTnLst>
-                    </p:cTn>
-                  </p:par>
-                  <p:par>
-                    <p:cTn id="18" fill="hold">
-                      <p:stCondLst>
-                        <p:cond delay="indefinite"/>
-                      </p:stCondLst>
-                      <p:childTnLst>
-                        <p:par>
-                          <p:cTn id="19" fill="hold">
-                            <p:stCondLst>
-                              <p:cond delay="0"/>
-                            </p:stCondLst>
-                            <p:childTnLst>
-                              <p:par>
-                                <p:cTn id="20" presetID="10" presetClass="entr" presetSubtype="0" fill="hold" nodeType="clickEffect">
-                                  <p:stCondLst>
-                                    <p:cond delay="0"/>
-                                  </p:stCondLst>
-                                  <p:childTnLst>
-                                    <p:set>
-                                      <p:cBhvr>
-                                        <p:cTn id="21" dur="1" fill="hold">
-                                          <p:stCondLst>
-                                            <p:cond delay="0"/>
-                                          </p:stCondLst>
-                                        </p:cTn>
-                                        <p:tgtEl>
-                                          <p:spTgt spid="4">
-                                            <p:txEl>
-                                              <p:pRg st="5" end="5"/>
-                                            </p:txEl>
-                                          </p:spTgt>
-                                        </p:tgtEl>
-                                        <p:attrNameLst>
-                                          <p:attrName>style.visibility</p:attrName>
-                                        </p:attrNameLst>
-                                      </p:cBhvr>
-                                      <p:to>
-                                        <p:strVal val="visible"/>
-                                      </p:to>
-                                    </p:set>
-                                    <p:animEffect transition="in" filter="fade">
-                                      <p:cBhvr>
-                                        <p:cTn id="22" dur="500"/>
                                         <p:tgtEl>
                                           <p:spTgt spid="4">
                                             <p:txEl>
@@ -5317,8 +5196,8 @@
           </a:p>
         </p:txBody>
       </p:sp>
-      <mc:AlternateContent xmlns:mc="http://schemas.openxmlformats.org/markup-compatibility/2006" xmlns:a14="http://schemas.microsoft.com/office/drawing/2010/main">
-        <mc:Choice Requires="a14">
+      <mc:AlternateContent xmlns:mc="http://schemas.openxmlformats.org/markup-compatibility/2006">
+        <mc:Choice xmlns:a14="http://schemas.microsoft.com/office/drawing/2010/main" Requires="a14">
           <p:sp>
             <p:nvSpPr>
               <p:cNvPr id="8" name="Content Placeholder 7">
@@ -5345,7 +5224,7 @@
                 </a:pPr>
                 <a:r>
                   <a:rPr lang="en-US" dirty="0"/>
-                  <a:t>Given a classifier, </a:t>
+                  <a:t>Consider a classifier, </a:t>
                 </a:r>
                 <a14:m>
                   <m:oMath xmlns:m="http://schemas.openxmlformats.org/officeDocument/2006/math">
@@ -5488,14 +5367,38 @@
                 </a14:m>
                 <a:r>
                   <a:rPr lang="en-US" dirty="0"/>
-                  <a:t>, the following counts can be computed:</a:t>
-                </a:r>
+                  <a:t> above which one is prepared to assign </a:t>
+                </a:r>
+                <a14:m>
+                  <m:oMath xmlns:m="http://schemas.openxmlformats.org/officeDocument/2006/math">
+                    <m:r>
+                      <a:rPr lang="en-US" i="1">
+                        <a:solidFill>
+                          <a:srgbClr val="0033CC"/>
+                        </a:solidFill>
+                        <a:latin typeface="Cambria Math" panose="02040503050406030204" pitchFamily="18" charset="0"/>
+                      </a:rPr>
+                      <m:t>𝑥</m:t>
+                    </m:r>
+                  </m:oMath>
+                </a14:m>
+                <a:r>
+                  <a:rPr lang="en-US" dirty="0"/>
+                  <a:t> to the “positive” (signal) class and below which one assigns it to the “negative” (background) class. </a:t>
+                </a:r>
+                <a:br>
+                  <a:rPr lang="en-US" dirty="0"/>
+                </a:br>
+                <a:endParaRPr lang="en-US" dirty="0"/>
               </a:p>
               <a:p>
                 <a:pPr marL="0" indent="0">
                   <a:buNone/>
                 </a:pPr>
-                <a:endParaRPr lang="en-US" dirty="0"/>
+                <a:r>
+                  <a:rPr lang="en-US" dirty="0"/>
+                  <a:t>The following counts can be computed:</a:t>
+                </a:r>
               </a:p>
               <a:p>
                 <a:pPr marL="457200" indent="-457200">
@@ -5519,6 +5422,18 @@
                         </m:ctrlPr>
                       </m:naryPr>
                       <m:sub>
+                        <m:r>
+                          <a:rPr lang="en-US" b="0" i="1" smtClean="0">
+                            <a:latin typeface="Cambria Math" panose="02040503050406030204" pitchFamily="18" charset="0"/>
+                          </a:rPr>
+                          <m:t>𝑖</m:t>
+                        </m:r>
+                        <m:r>
+                          <a:rPr lang="en-US" b="0" i="1" smtClean="0">
+                            <a:latin typeface="Cambria Math" panose="02040503050406030204" pitchFamily="18" charset="0"/>
+                          </a:rPr>
+                          <m:t>, </m:t>
+                        </m:r>
                         <m:sSub>
                           <m:sSubPr>
                             <m:ctrlPr>
@@ -5531,6 +5446,15 @@
                             </m:ctrlPr>
                           </m:sSubPr>
                           <m:e>
+                            <m:r>
+                              <a:rPr lang="en-US" b="1" i="1" smtClean="0">
+                                <a:solidFill>
+                                  <a:srgbClr val="0033CC"/>
+                                </a:solidFill>
+                                <a:latin typeface="Cambria Math" panose="02040503050406030204" pitchFamily="18" charset="0"/>
+                              </a:rPr>
+                              <m:t> </m:t>
+                            </m:r>
                             <m:r>
                               <m:rPr>
                                 <m:brk m:alnAt="7"/>
@@ -5684,6 +5608,18 @@
                         </m:ctrlPr>
                       </m:naryPr>
                       <m:sub>
+                        <m:r>
+                          <a:rPr lang="en-US" b="0" i="1" smtClean="0">
+                            <a:latin typeface="Cambria Math" panose="02040503050406030204" pitchFamily="18" charset="0"/>
+                          </a:rPr>
+                          <m:t>𝑖</m:t>
+                        </m:r>
+                        <m:r>
+                          <a:rPr lang="en-US" b="0" i="1" smtClean="0">
+                            <a:latin typeface="Cambria Math" panose="02040503050406030204" pitchFamily="18" charset="0"/>
+                          </a:rPr>
+                          <m:t>,   </m:t>
+                        </m:r>
                         <m:sSub>
                           <m:sSubPr>
                             <m:ctrlPr>
@@ -5848,6 +5784,24 @@
                         </m:ctrlPr>
                       </m:naryPr>
                       <m:sub>
+                        <m:r>
+                          <a:rPr lang="en-US" b="0" i="1" smtClean="0">
+                            <a:latin typeface="Cambria Math" panose="02040503050406030204" pitchFamily="18" charset="0"/>
+                          </a:rPr>
+                          <m:t>𝑖</m:t>
+                        </m:r>
+                        <m:r>
+                          <a:rPr lang="en-US" b="0" i="1" smtClean="0">
+                            <a:latin typeface="Cambria Math" panose="02040503050406030204" pitchFamily="18" charset="0"/>
+                          </a:rPr>
+                          <m:t>, </m:t>
+                        </m:r>
+                        <m:r>
+                          <a:rPr lang="en-US" b="1" i="1" smtClean="0">
+                            <a:latin typeface="Cambria Math" panose="02040503050406030204" pitchFamily="18" charset="0"/>
+                          </a:rPr>
+                          <m:t> </m:t>
+                        </m:r>
                         <m:sSub>
                           <m:sSubPr>
                             <m:ctrlPr>
@@ -6026,6 +5980,24 @@
                           </m:sSubPr>
                           <m:e>
                             <m:r>
+                              <a:rPr lang="en-US" b="1" i="1" smtClean="0">
+                                <a:solidFill>
+                                  <a:schemeClr val="tx1"/>
+                                </a:solidFill>
+                                <a:latin typeface="Cambria Math" panose="02040503050406030204" pitchFamily="18" charset="0"/>
+                              </a:rPr>
+                              <m:t>𝒊</m:t>
+                            </m:r>
+                            <m:r>
+                              <a:rPr lang="en-US" b="1" i="1" smtClean="0">
+                                <a:solidFill>
+                                  <a:schemeClr val="tx1"/>
+                                </a:solidFill>
+                                <a:latin typeface="Cambria Math" panose="02040503050406030204" pitchFamily="18" charset="0"/>
+                              </a:rPr>
+                              <m:t>,   </m:t>
+                            </m:r>
+                            <m:r>
                               <m:rPr>
                                 <m:brk m:alnAt="7"/>
                               </m:rPr>
@@ -6159,12 +6131,6 @@
                 <a:pPr marL="0" indent="0">
                   <a:buNone/>
                 </a:pPr>
-                <a:endParaRPr lang="en-US" dirty="0"/>
-              </a:p>
-              <a:p>
-                <a:pPr marL="0" indent="0">
-                  <a:buNone/>
-                </a:pPr>
                 <a:r>
                   <a:rPr lang="en-US" dirty="0">
                     <a:solidFill>
@@ -6256,7 +6222,7 @@
             </p:txBody>
           </p:sp>
         </mc:Choice>
-        <mc:Fallback xmlns="">
+        <mc:Fallback>
           <p:sp>
             <p:nvSpPr>
               <p:cNvPr id="8" name="Content Placeholder 7">
@@ -6277,7 +6243,7 @@
               <a:blipFill>
                 <a:blip r:embed="rId2"/>
                 <a:stretch>
-                  <a:fillRect l="-1305" t="-1316" r="-816"/>
+                  <a:fillRect l="-1305" t="-1316" r="-1631" b="-7895"/>
                 </a:stretch>
               </a:blipFill>
             </p:spPr>
@@ -6318,6 +6284,323 @@
       </p:transition>
     </mc:Fallback>
   </mc:AlternateContent>
+  <p:timing>
+    <p:tnLst>
+      <p:par>
+        <p:cTn id="1" dur="indefinite" restart="never" nodeType="tmRoot">
+          <p:childTnLst>
+            <p:seq concurrent="1" nextAc="seek">
+              <p:cTn id="2" dur="indefinite" nodeType="mainSeq">
+                <p:childTnLst>
+                  <p:par>
+                    <p:cTn id="3" fill="hold">
+                      <p:stCondLst>
+                        <p:cond delay="indefinite"/>
+                      </p:stCondLst>
+                      <p:childTnLst>
+                        <p:par>
+                          <p:cTn id="4" fill="hold">
+                            <p:stCondLst>
+                              <p:cond delay="0"/>
+                            </p:stCondLst>
+                            <p:childTnLst>
+                              <p:par>
+                                <p:cTn id="5" presetID="10" presetClass="entr" presetSubtype="0" fill="hold" nodeType="clickEffect">
+                                  <p:stCondLst>
+                                    <p:cond delay="0"/>
+                                  </p:stCondLst>
+                                  <p:childTnLst>
+                                    <p:set>
+                                      <p:cBhvr>
+                                        <p:cTn id="6" dur="1" fill="hold">
+                                          <p:stCondLst>
+                                            <p:cond delay="0"/>
+                                          </p:stCondLst>
+                                        </p:cTn>
+                                        <p:tgtEl>
+                                          <p:spTgt spid="8">
+                                            <p:txEl>
+                                              <p:pRg st="1" end="1"/>
+                                            </p:txEl>
+                                          </p:spTgt>
+                                        </p:tgtEl>
+                                        <p:attrNameLst>
+                                          <p:attrName>style.visibility</p:attrName>
+                                        </p:attrNameLst>
+                                      </p:cBhvr>
+                                      <p:to>
+                                        <p:strVal val="visible"/>
+                                      </p:to>
+                                    </p:set>
+                                    <p:animEffect transition="in" filter="fade">
+                                      <p:cBhvr>
+                                        <p:cTn id="7" dur="500"/>
+                                        <p:tgtEl>
+                                          <p:spTgt spid="8">
+                                            <p:txEl>
+                                              <p:pRg st="1" end="1"/>
+                                            </p:txEl>
+                                          </p:spTgt>
+                                        </p:tgtEl>
+                                      </p:cBhvr>
+                                    </p:animEffect>
+                                  </p:childTnLst>
+                                </p:cTn>
+                              </p:par>
+                              <p:par>
+                                <p:cTn id="8" presetID="10" presetClass="entr" presetSubtype="0" fill="hold" nodeType="withEffect">
+                                  <p:stCondLst>
+                                    <p:cond delay="0"/>
+                                  </p:stCondLst>
+                                  <p:childTnLst>
+                                    <p:set>
+                                      <p:cBhvr>
+                                        <p:cTn id="9" dur="1" fill="hold">
+                                          <p:stCondLst>
+                                            <p:cond delay="0"/>
+                                          </p:stCondLst>
+                                        </p:cTn>
+                                        <p:tgtEl>
+                                          <p:spTgt spid="8">
+                                            <p:txEl>
+                                              <p:pRg st="2" end="2"/>
+                                            </p:txEl>
+                                          </p:spTgt>
+                                        </p:tgtEl>
+                                        <p:attrNameLst>
+                                          <p:attrName>style.visibility</p:attrName>
+                                        </p:attrNameLst>
+                                      </p:cBhvr>
+                                      <p:to>
+                                        <p:strVal val="visible"/>
+                                      </p:to>
+                                    </p:set>
+                                    <p:animEffect transition="in" filter="fade">
+                                      <p:cBhvr>
+                                        <p:cTn id="10" dur="500"/>
+                                        <p:tgtEl>
+                                          <p:spTgt spid="8">
+                                            <p:txEl>
+                                              <p:pRg st="2" end="2"/>
+                                            </p:txEl>
+                                          </p:spTgt>
+                                        </p:tgtEl>
+                                      </p:cBhvr>
+                                    </p:animEffect>
+                                  </p:childTnLst>
+                                </p:cTn>
+                              </p:par>
+                            </p:childTnLst>
+                          </p:cTn>
+                        </p:par>
+                      </p:childTnLst>
+                    </p:cTn>
+                  </p:par>
+                  <p:par>
+                    <p:cTn id="11" fill="hold">
+                      <p:stCondLst>
+                        <p:cond delay="indefinite"/>
+                      </p:stCondLst>
+                      <p:childTnLst>
+                        <p:par>
+                          <p:cTn id="12" fill="hold">
+                            <p:stCondLst>
+                              <p:cond delay="0"/>
+                            </p:stCondLst>
+                            <p:childTnLst>
+                              <p:par>
+                                <p:cTn id="13" presetID="10" presetClass="entr" presetSubtype="0" fill="hold" nodeType="clickEffect">
+                                  <p:stCondLst>
+                                    <p:cond delay="0"/>
+                                  </p:stCondLst>
+                                  <p:childTnLst>
+                                    <p:set>
+                                      <p:cBhvr>
+                                        <p:cTn id="14" dur="1" fill="hold">
+                                          <p:stCondLst>
+                                            <p:cond delay="0"/>
+                                          </p:stCondLst>
+                                        </p:cTn>
+                                        <p:tgtEl>
+                                          <p:spTgt spid="8">
+                                            <p:txEl>
+                                              <p:pRg st="3" end="3"/>
+                                            </p:txEl>
+                                          </p:spTgt>
+                                        </p:tgtEl>
+                                        <p:attrNameLst>
+                                          <p:attrName>style.visibility</p:attrName>
+                                        </p:attrNameLst>
+                                      </p:cBhvr>
+                                      <p:to>
+                                        <p:strVal val="visible"/>
+                                      </p:to>
+                                    </p:set>
+                                    <p:animEffect transition="in" filter="fade">
+                                      <p:cBhvr>
+                                        <p:cTn id="15" dur="500"/>
+                                        <p:tgtEl>
+                                          <p:spTgt spid="8">
+                                            <p:txEl>
+                                              <p:pRg st="3" end="3"/>
+                                            </p:txEl>
+                                          </p:spTgt>
+                                        </p:tgtEl>
+                                      </p:cBhvr>
+                                    </p:animEffect>
+                                  </p:childTnLst>
+                                </p:cTn>
+                              </p:par>
+                            </p:childTnLst>
+                          </p:cTn>
+                        </p:par>
+                      </p:childTnLst>
+                    </p:cTn>
+                  </p:par>
+                  <p:par>
+                    <p:cTn id="16" fill="hold">
+                      <p:stCondLst>
+                        <p:cond delay="indefinite"/>
+                      </p:stCondLst>
+                      <p:childTnLst>
+                        <p:par>
+                          <p:cTn id="17" fill="hold">
+                            <p:stCondLst>
+                              <p:cond delay="0"/>
+                            </p:stCondLst>
+                            <p:childTnLst>
+                              <p:par>
+                                <p:cTn id="18" presetID="10" presetClass="entr" presetSubtype="0" fill="hold" nodeType="clickEffect">
+                                  <p:stCondLst>
+                                    <p:cond delay="0"/>
+                                  </p:stCondLst>
+                                  <p:childTnLst>
+                                    <p:set>
+                                      <p:cBhvr>
+                                        <p:cTn id="19" dur="1" fill="hold">
+                                          <p:stCondLst>
+                                            <p:cond delay="0"/>
+                                          </p:stCondLst>
+                                        </p:cTn>
+                                        <p:tgtEl>
+                                          <p:spTgt spid="8">
+                                            <p:txEl>
+                                              <p:pRg st="4" end="4"/>
+                                            </p:txEl>
+                                          </p:spTgt>
+                                        </p:tgtEl>
+                                        <p:attrNameLst>
+                                          <p:attrName>style.visibility</p:attrName>
+                                        </p:attrNameLst>
+                                      </p:cBhvr>
+                                      <p:to>
+                                        <p:strVal val="visible"/>
+                                      </p:to>
+                                    </p:set>
+                                    <p:animEffect transition="in" filter="fade">
+                                      <p:cBhvr>
+                                        <p:cTn id="20" dur="500"/>
+                                        <p:tgtEl>
+                                          <p:spTgt spid="8">
+                                            <p:txEl>
+                                              <p:pRg st="4" end="4"/>
+                                            </p:txEl>
+                                          </p:spTgt>
+                                        </p:tgtEl>
+                                      </p:cBhvr>
+                                    </p:animEffect>
+                                  </p:childTnLst>
+                                </p:cTn>
+                              </p:par>
+                            </p:childTnLst>
+                          </p:cTn>
+                        </p:par>
+                      </p:childTnLst>
+                    </p:cTn>
+                  </p:par>
+                  <p:par>
+                    <p:cTn id="21" fill="hold">
+                      <p:stCondLst>
+                        <p:cond delay="indefinite"/>
+                      </p:stCondLst>
+                      <p:childTnLst>
+                        <p:par>
+                          <p:cTn id="22" fill="hold">
+                            <p:stCondLst>
+                              <p:cond delay="0"/>
+                            </p:stCondLst>
+                            <p:childTnLst>
+                              <p:par>
+                                <p:cTn id="23" presetID="10" presetClass="entr" presetSubtype="0" fill="hold" nodeType="clickEffect">
+                                  <p:stCondLst>
+                                    <p:cond delay="0"/>
+                                  </p:stCondLst>
+                                  <p:childTnLst>
+                                    <p:set>
+                                      <p:cBhvr>
+                                        <p:cTn id="24" dur="1" fill="hold">
+                                          <p:stCondLst>
+                                            <p:cond delay="0"/>
+                                          </p:stCondLst>
+                                        </p:cTn>
+                                        <p:tgtEl>
+                                          <p:spTgt spid="8">
+                                            <p:txEl>
+                                              <p:pRg st="5" end="5"/>
+                                            </p:txEl>
+                                          </p:spTgt>
+                                        </p:tgtEl>
+                                        <p:attrNameLst>
+                                          <p:attrName>style.visibility</p:attrName>
+                                        </p:attrNameLst>
+                                      </p:cBhvr>
+                                      <p:to>
+                                        <p:strVal val="visible"/>
+                                      </p:to>
+                                    </p:set>
+                                    <p:animEffect transition="in" filter="fade">
+                                      <p:cBhvr>
+                                        <p:cTn id="25" dur="500"/>
+                                        <p:tgtEl>
+                                          <p:spTgt spid="8">
+                                            <p:txEl>
+                                              <p:pRg st="5" end="5"/>
+                                            </p:txEl>
+                                          </p:spTgt>
+                                        </p:tgtEl>
+                                      </p:cBhvr>
+                                    </p:animEffect>
+                                  </p:childTnLst>
+                                </p:cTn>
+                              </p:par>
+                            </p:childTnLst>
+                          </p:cTn>
+                        </p:par>
+                      </p:childTnLst>
+                    </p:cTn>
+                  </p:par>
+                </p:childTnLst>
+              </p:cTn>
+              <p:prevCondLst>
+                <p:cond evt="onPrev" delay="0">
+                  <p:tgtEl>
+                    <p:sldTgt/>
+                  </p:tgtEl>
+                </p:cond>
+              </p:prevCondLst>
+              <p:nextCondLst>
+                <p:cond evt="onNext" delay="0">
+                  <p:tgtEl>
+                    <p:sldTgt/>
+                  </p:tgtEl>
+                </p:cond>
+              </p:nextCondLst>
+            </p:seq>
+          </p:childTnLst>
+        </p:cTn>
+      </p:par>
+    </p:tnLst>
+  </p:timing>
 </p:sld>
 </file>
 
@@ -6377,8 +6660,8 @@
           </a:p>
         </p:txBody>
       </p:sp>
-      <mc:AlternateContent xmlns:mc="http://schemas.openxmlformats.org/markup-compatibility/2006" xmlns:a14="http://schemas.microsoft.com/office/drawing/2010/main">
-        <mc:Choice Requires="a14">
+      <mc:AlternateContent xmlns:mc="http://schemas.openxmlformats.org/markup-compatibility/2006">
+        <mc:Choice xmlns:a14="http://schemas.microsoft.com/office/drawing/2010/main" Requires="a14">
           <p:sp>
             <p:nvSpPr>
               <p:cNvPr id="8" name="Content Placeholder 7">
@@ -6425,6 +6708,18 @@
                         </m:ctrlPr>
                       </m:naryPr>
                       <m:sub>
+                        <m:r>
+                          <a:rPr lang="en-US" b="0" i="1" smtClean="0">
+                            <a:latin typeface="Cambria Math" panose="02040503050406030204" pitchFamily="18" charset="0"/>
+                          </a:rPr>
+                          <m:t>𝑖</m:t>
+                        </m:r>
+                        <m:r>
+                          <a:rPr lang="en-US" b="0" i="1" smtClean="0">
+                            <a:latin typeface="Cambria Math" panose="02040503050406030204" pitchFamily="18" charset="0"/>
+                          </a:rPr>
+                          <m:t>,   </m:t>
+                        </m:r>
                         <m:sSub>
                           <m:sSubPr>
                             <m:ctrlPr>
@@ -6603,6 +6898,18 @@
                             </m:ctrlPr>
                           </m:sSubPr>
                           <m:e>
+                            <m:r>
+                              <a:rPr lang="en-US" b="0" i="1" smtClean="0">
+                                <a:latin typeface="Cambria Math" panose="02040503050406030204" pitchFamily="18" charset="0"/>
+                              </a:rPr>
+                              <m:t>𝑖</m:t>
+                            </m:r>
+                            <m:r>
+                              <a:rPr lang="en-US" b="0" i="1" smtClean="0">
+                                <a:latin typeface="Cambria Math" panose="02040503050406030204" pitchFamily="18" charset="0"/>
+                              </a:rPr>
+                              <m:t>,   </m:t>
+                            </m:r>
                             <m:r>
                               <m:rPr>
                                 <m:brk m:alnAt="7"/>
@@ -6854,6 +7161,18 @@
                         </m:ctrlPr>
                       </m:naryPr>
                       <m:sub>
+                        <m:r>
+                          <a:rPr lang="en-US" b="0" i="1" smtClean="0">
+                            <a:latin typeface="Cambria Math" panose="02040503050406030204" pitchFamily="18" charset="0"/>
+                          </a:rPr>
+                          <m:t>𝑖</m:t>
+                        </m:r>
+                        <m:r>
+                          <a:rPr lang="en-US" b="0" i="1" smtClean="0">
+                            <a:latin typeface="Cambria Math" panose="02040503050406030204" pitchFamily="18" charset="0"/>
+                          </a:rPr>
+                          <m:t>,   </m:t>
+                        </m:r>
                         <m:sSub>
                           <m:sSubPr>
                             <m:ctrlPr>
@@ -7003,6 +7322,18 @@
                         </m:ctrlPr>
                       </m:naryPr>
                       <m:sub>
+                        <m:r>
+                          <a:rPr lang="en-US" b="0" i="1" smtClean="0">
+                            <a:latin typeface="Cambria Math" panose="02040503050406030204" pitchFamily="18" charset="0"/>
+                          </a:rPr>
+                          <m:t>𝑖</m:t>
+                        </m:r>
+                        <m:r>
+                          <a:rPr lang="en-US" b="0" i="1" smtClean="0">
+                            <a:latin typeface="Cambria Math" panose="02040503050406030204" pitchFamily="18" charset="0"/>
+                          </a:rPr>
+                          <m:t>,   </m:t>
+                        </m:r>
                         <m:sSub>
                           <m:sSubPr>
                             <m:ctrlPr>
@@ -7147,7 +7478,7 @@
             </p:txBody>
           </p:sp>
         </mc:Choice>
-        <mc:Fallback xmlns="">
+        <mc:Fallback>
           <p:sp>
             <p:nvSpPr>
               <p:cNvPr id="8" name="Content Placeholder 7">
@@ -7172,7 +7503,7 @@
               <a:blipFill>
                 <a:blip r:embed="rId2"/>
                 <a:stretch>
-                  <a:fillRect l="-1205" t="-12368" b="-20789"/>
+                  <a:fillRect l="-1205" t="-12368" b="-21579"/>
                 </a:stretch>
               </a:blipFill>
             </p:spPr>
@@ -7346,8 +7677,8 @@
           </a:p>
         </p:txBody>
       </p:sp>
-      <mc:AlternateContent xmlns:mc="http://schemas.openxmlformats.org/markup-compatibility/2006" xmlns:a14="http://schemas.microsoft.com/office/drawing/2010/main">
-        <mc:Choice Requires="a14">
+      <mc:AlternateContent xmlns:mc="http://schemas.openxmlformats.org/markup-compatibility/2006">
+        <mc:Choice xmlns:a14="http://schemas.microsoft.com/office/drawing/2010/main" Requires="a14">
           <p:sp>
             <p:nvSpPr>
               <p:cNvPr id="8" name="Content Placeholder 7">
@@ -7394,6 +7725,18 @@
                         </m:ctrlPr>
                       </m:naryPr>
                       <m:sub>
+                        <m:r>
+                          <a:rPr lang="en-US" b="0" i="1" smtClean="0">
+                            <a:latin typeface="Cambria Math" panose="02040503050406030204" pitchFamily="18" charset="0"/>
+                          </a:rPr>
+                          <m:t>𝑖</m:t>
+                        </m:r>
+                        <m:r>
+                          <a:rPr lang="en-US" b="0" i="1" smtClean="0">
+                            <a:latin typeface="Cambria Math" panose="02040503050406030204" pitchFamily="18" charset="0"/>
+                          </a:rPr>
+                          <m:t>,   </m:t>
+                        </m:r>
                         <m:sSub>
                           <m:sSubPr>
                             <m:ctrlPr>
@@ -7553,6 +7896,18 @@
                           </m:sSubPr>
                           <m:e>
                             <m:r>
+                              <a:rPr lang="en-US" b="0" i="1" smtClean="0">
+                                <a:latin typeface="Cambria Math" panose="02040503050406030204" pitchFamily="18" charset="0"/>
+                              </a:rPr>
+                              <m:t>𝑖</m:t>
+                            </m:r>
+                            <m:r>
+                              <a:rPr lang="en-US" b="0" i="1" smtClean="0">
+                                <a:latin typeface="Cambria Math" panose="02040503050406030204" pitchFamily="18" charset="0"/>
+                              </a:rPr>
+                              <m:t>,   </m:t>
+                            </m:r>
+                            <m:r>
                               <m:rPr>
                                 <m:brk m:alnAt="7"/>
                               </m:rPr>
@@ -7785,6 +8140,18 @@
                           </m:sSubPr>
                           <m:e>
                             <m:r>
+                              <a:rPr lang="en-US" b="0" i="1" smtClean="0">
+                                <a:latin typeface="Cambria Math" panose="02040503050406030204" pitchFamily="18" charset="0"/>
+                              </a:rPr>
+                              <m:t>𝑖</m:t>
+                            </m:r>
+                            <m:r>
+                              <a:rPr lang="en-US" b="0" i="1" smtClean="0">
+                                <a:latin typeface="Cambria Math" panose="02040503050406030204" pitchFamily="18" charset="0"/>
+                              </a:rPr>
+                              <m:t>,   </m:t>
+                            </m:r>
+                            <m:r>
                               <m:rPr>
                                 <m:brk m:alnAt="7"/>
                               </m:rPr>
@@ -7934,6 +8301,18 @@
                           </m:sSubPr>
                           <m:e>
                             <m:r>
+                              <a:rPr lang="en-US" b="0" i="1" smtClean="0">
+                                <a:latin typeface="Cambria Math" panose="02040503050406030204" pitchFamily="18" charset="0"/>
+                              </a:rPr>
+                              <m:t>𝑖</m:t>
+                            </m:r>
+                            <m:r>
+                              <a:rPr lang="en-US" b="0" i="1" smtClean="0">
+                                <a:latin typeface="Cambria Math" panose="02040503050406030204" pitchFamily="18" charset="0"/>
+                              </a:rPr>
+                              <m:t>,   </m:t>
+                            </m:r>
+                            <m:r>
                               <m:rPr>
                                 <m:brk m:alnAt="7"/>
                               </m:rPr>
@@ -8068,7 +8447,7 @@
             </p:txBody>
           </p:sp>
         </mc:Choice>
-        <mc:Fallback xmlns="">
+        <mc:Fallback>
           <p:sp>
             <p:nvSpPr>
               <p:cNvPr id="8" name="Content Placeholder 7">
@@ -8093,7 +8472,7 @@
               <a:blipFill>
                 <a:blip r:embed="rId2"/>
                 <a:stretch>
-                  <a:fillRect l="-1205" t="-12368" b="-20789"/>
+                  <a:fillRect l="-1205" t="-12368" b="-21579"/>
                 </a:stretch>
               </a:blipFill>
             </p:spPr>
@@ -10208,8 +10587,8 @@
           <a:chExt cx="0" cy="0"/>
         </a:xfrm>
       </p:grpSpPr>
-      <mc:AlternateContent xmlns:mc="http://schemas.openxmlformats.org/markup-compatibility/2006" xmlns:a14="http://schemas.microsoft.com/office/drawing/2010/main">
-        <mc:Choice Requires="a14">
+      <mc:AlternateContent xmlns:mc="http://schemas.openxmlformats.org/markup-compatibility/2006">
+        <mc:Choice xmlns:a14="http://schemas.microsoft.com/office/drawing/2010/main" Requires="a14">
           <p:sp>
             <p:nvSpPr>
               <p:cNvPr id="4" name="Content Placeholder 3">
@@ -10613,7 +10992,7 @@
                       </a:outerShdw>
                     </a:effectLst>
                   </a:rPr>
-                  <a:t>which is often referred to as the likelihood ratio trick. </a:t>
+                  <a:t>The above is often referred to as the likelihood ratio trick. </a:t>
                 </a:r>
               </a:p>
               <a:p>
@@ -10812,7 +11191,7 @@
             </p:txBody>
           </p:sp>
         </mc:Choice>
-        <mc:Fallback xmlns="">
+        <mc:Fallback>
           <p:sp>
             <p:nvSpPr>
               <p:cNvPr id="4" name="Content Placeholder 3">
@@ -10954,8 +11333,8 @@
           </a:p>
         </p:txBody>
       </p:sp>
-      <mc:AlternateContent xmlns:mc="http://schemas.openxmlformats.org/markup-compatibility/2006" xmlns:a14="http://schemas.microsoft.com/office/drawing/2010/main">
-        <mc:Choice Requires="a14">
+      <mc:AlternateContent xmlns:mc="http://schemas.openxmlformats.org/markup-compatibility/2006">
+        <mc:Choice xmlns:a14="http://schemas.microsoft.com/office/drawing/2010/main" Requires="a14">
           <p:sp>
             <p:nvSpPr>
               <p:cNvPr id="8" name="Content Placeholder 7">
@@ -11457,9 +11836,38 @@
                       <a:srgbClr val="0033CC"/>
                     </a:solidFill>
                   </a:rPr>
-                  <a:t>].</a:t>
-                </a:r>
-                <a:endParaRPr lang="en-US" dirty="0"/>
+                  <a:t>] </a:t>
+                </a:r>
+                <a:r>
+                  <a:rPr lang="en-US" dirty="0"/>
+                  <a:t>of sample size </a:t>
+                </a:r>
+                <a14:m>
+                  <m:oMath xmlns:m="http://schemas.openxmlformats.org/officeDocument/2006/math">
+                    <m:r>
+                      <a:rPr lang="en-US" b="0" i="1" smtClean="0">
+                        <a:solidFill>
+                          <a:srgbClr val="0033CC"/>
+                        </a:solidFill>
+                        <a:latin typeface="Cambria Math" panose="02040503050406030204" pitchFamily="18" charset="0"/>
+                      </a:rPr>
+                      <m:t>2</m:t>
+                    </m:r>
+                    <m:r>
+                      <a:rPr lang="en-US" b="0" i="1" smtClean="0">
+                        <a:solidFill>
+                          <a:srgbClr val="0033CC"/>
+                        </a:solidFill>
+                        <a:latin typeface="Cambria Math" panose="02040503050406030204" pitchFamily="18" charset="0"/>
+                      </a:rPr>
+                      <m:t>𝑁</m:t>
+                    </m:r>
+                  </m:oMath>
+                </a14:m>
+                <a:r>
+                  <a:rPr lang="en-US" dirty="0"/>
+                  <a:t>.</a:t>
+                </a:r>
               </a:p>
               <a:p>
                 <a:pPr marL="457200" indent="-457200">
@@ -11695,7 +12103,7 @@
             </p:txBody>
           </p:sp>
         </mc:Choice>
-        <mc:Fallback xmlns="">
+        <mc:Fallback>
           <p:sp>
             <p:nvSpPr>
               <p:cNvPr id="8" name="Content Placeholder 7">
@@ -11757,6 +12165,348 @@
       </p:transition>
     </mc:Fallback>
   </mc:AlternateContent>
+  <p:timing>
+    <p:tnLst>
+      <p:par>
+        <p:cTn id="1" dur="indefinite" restart="never" nodeType="tmRoot">
+          <p:childTnLst>
+            <p:seq concurrent="1" nextAc="seek">
+              <p:cTn id="2" dur="indefinite" nodeType="mainSeq">
+                <p:childTnLst>
+                  <p:par>
+                    <p:cTn id="3" fill="hold">
+                      <p:stCondLst>
+                        <p:cond delay="indefinite"/>
+                      </p:stCondLst>
+                      <p:childTnLst>
+                        <p:par>
+                          <p:cTn id="4" fill="hold">
+                            <p:stCondLst>
+                              <p:cond delay="0"/>
+                            </p:stCondLst>
+                            <p:childTnLst>
+                              <p:par>
+                                <p:cTn id="5" presetID="10" presetClass="entr" presetSubtype="0" fill="hold" nodeType="clickEffect">
+                                  <p:stCondLst>
+                                    <p:cond delay="0"/>
+                                  </p:stCondLst>
+                                  <p:childTnLst>
+                                    <p:set>
+                                      <p:cBhvr>
+                                        <p:cTn id="6" dur="1" fill="hold">
+                                          <p:stCondLst>
+                                            <p:cond delay="0"/>
+                                          </p:stCondLst>
+                                        </p:cTn>
+                                        <p:tgtEl>
+                                          <p:spTgt spid="8">
+                                            <p:txEl>
+                                              <p:pRg st="1" end="1"/>
+                                            </p:txEl>
+                                          </p:spTgt>
+                                        </p:tgtEl>
+                                        <p:attrNameLst>
+                                          <p:attrName>style.visibility</p:attrName>
+                                        </p:attrNameLst>
+                                      </p:cBhvr>
+                                      <p:to>
+                                        <p:strVal val="visible"/>
+                                      </p:to>
+                                    </p:set>
+                                    <p:animEffect transition="in" filter="fade">
+                                      <p:cBhvr>
+                                        <p:cTn id="7" dur="500"/>
+                                        <p:tgtEl>
+                                          <p:spTgt spid="8">
+                                            <p:txEl>
+                                              <p:pRg st="1" end="1"/>
+                                            </p:txEl>
+                                          </p:spTgt>
+                                        </p:tgtEl>
+                                      </p:cBhvr>
+                                    </p:animEffect>
+                                  </p:childTnLst>
+                                </p:cTn>
+                              </p:par>
+                              <p:par>
+                                <p:cTn id="8" presetID="10" presetClass="entr" presetSubtype="0" fill="hold" nodeType="withEffect">
+                                  <p:stCondLst>
+                                    <p:cond delay="0"/>
+                                  </p:stCondLst>
+                                  <p:childTnLst>
+                                    <p:set>
+                                      <p:cBhvr>
+                                        <p:cTn id="9" dur="1" fill="hold">
+                                          <p:stCondLst>
+                                            <p:cond delay="0"/>
+                                          </p:stCondLst>
+                                        </p:cTn>
+                                        <p:tgtEl>
+                                          <p:spTgt spid="8">
+                                            <p:txEl>
+                                              <p:pRg st="2" end="2"/>
+                                            </p:txEl>
+                                          </p:spTgt>
+                                        </p:tgtEl>
+                                        <p:attrNameLst>
+                                          <p:attrName>style.visibility</p:attrName>
+                                        </p:attrNameLst>
+                                      </p:cBhvr>
+                                      <p:to>
+                                        <p:strVal val="visible"/>
+                                      </p:to>
+                                    </p:set>
+                                    <p:animEffect transition="in" filter="fade">
+                                      <p:cBhvr>
+                                        <p:cTn id="10" dur="500"/>
+                                        <p:tgtEl>
+                                          <p:spTgt spid="8">
+                                            <p:txEl>
+                                              <p:pRg st="2" end="2"/>
+                                            </p:txEl>
+                                          </p:spTgt>
+                                        </p:tgtEl>
+                                      </p:cBhvr>
+                                    </p:animEffect>
+                                  </p:childTnLst>
+                                </p:cTn>
+                              </p:par>
+                              <p:par>
+                                <p:cTn id="11" presetID="10" presetClass="entr" presetSubtype="0" fill="hold" nodeType="withEffect">
+                                  <p:stCondLst>
+                                    <p:cond delay="0"/>
+                                  </p:stCondLst>
+                                  <p:childTnLst>
+                                    <p:set>
+                                      <p:cBhvr>
+                                        <p:cTn id="12" dur="1" fill="hold">
+                                          <p:stCondLst>
+                                            <p:cond delay="0"/>
+                                          </p:stCondLst>
+                                        </p:cTn>
+                                        <p:tgtEl>
+                                          <p:spTgt spid="8">
+                                            <p:txEl>
+                                              <p:pRg st="6" end="6"/>
+                                            </p:txEl>
+                                          </p:spTgt>
+                                        </p:tgtEl>
+                                        <p:attrNameLst>
+                                          <p:attrName>style.visibility</p:attrName>
+                                        </p:attrNameLst>
+                                      </p:cBhvr>
+                                      <p:to>
+                                        <p:strVal val="visible"/>
+                                      </p:to>
+                                    </p:set>
+                                    <p:animEffect transition="in" filter="fade">
+                                      <p:cBhvr>
+                                        <p:cTn id="13" dur="500"/>
+                                        <p:tgtEl>
+                                          <p:spTgt spid="8">
+                                            <p:txEl>
+                                              <p:pRg st="6" end="6"/>
+                                            </p:txEl>
+                                          </p:spTgt>
+                                        </p:tgtEl>
+                                      </p:cBhvr>
+                                    </p:animEffect>
+                                  </p:childTnLst>
+                                </p:cTn>
+                              </p:par>
+                            </p:childTnLst>
+                          </p:cTn>
+                        </p:par>
+                      </p:childTnLst>
+                    </p:cTn>
+                  </p:par>
+                  <p:par>
+                    <p:cTn id="14" fill="hold">
+                      <p:stCondLst>
+                        <p:cond delay="indefinite"/>
+                      </p:stCondLst>
+                      <p:childTnLst>
+                        <p:par>
+                          <p:cTn id="15" fill="hold">
+                            <p:stCondLst>
+                              <p:cond delay="0"/>
+                            </p:stCondLst>
+                            <p:childTnLst>
+                              <p:par>
+                                <p:cTn id="16" presetID="10" presetClass="entr" presetSubtype="0" fill="hold" nodeType="clickEffect">
+                                  <p:stCondLst>
+                                    <p:cond delay="0"/>
+                                  </p:stCondLst>
+                                  <p:childTnLst>
+                                    <p:set>
+                                      <p:cBhvr>
+                                        <p:cTn id="17" dur="1" fill="hold">
+                                          <p:stCondLst>
+                                            <p:cond delay="0"/>
+                                          </p:stCondLst>
+                                        </p:cTn>
+                                        <p:tgtEl>
+                                          <p:spTgt spid="8">
+                                            <p:txEl>
+                                              <p:pRg st="3" end="3"/>
+                                            </p:txEl>
+                                          </p:spTgt>
+                                        </p:tgtEl>
+                                        <p:attrNameLst>
+                                          <p:attrName>style.visibility</p:attrName>
+                                        </p:attrNameLst>
+                                      </p:cBhvr>
+                                      <p:to>
+                                        <p:strVal val="visible"/>
+                                      </p:to>
+                                    </p:set>
+                                    <p:animEffect transition="in" filter="fade">
+                                      <p:cBhvr>
+                                        <p:cTn id="18" dur="500"/>
+                                        <p:tgtEl>
+                                          <p:spTgt spid="8">
+                                            <p:txEl>
+                                              <p:pRg st="3" end="3"/>
+                                            </p:txEl>
+                                          </p:spTgt>
+                                        </p:tgtEl>
+                                      </p:cBhvr>
+                                    </p:animEffect>
+                                  </p:childTnLst>
+                                </p:cTn>
+                              </p:par>
+                            </p:childTnLst>
+                          </p:cTn>
+                        </p:par>
+                      </p:childTnLst>
+                    </p:cTn>
+                  </p:par>
+                  <p:par>
+                    <p:cTn id="19" fill="hold">
+                      <p:stCondLst>
+                        <p:cond delay="indefinite"/>
+                      </p:stCondLst>
+                      <p:childTnLst>
+                        <p:par>
+                          <p:cTn id="20" fill="hold">
+                            <p:stCondLst>
+                              <p:cond delay="0"/>
+                            </p:stCondLst>
+                            <p:childTnLst>
+                              <p:par>
+                                <p:cTn id="21" presetID="10" presetClass="entr" presetSubtype="0" fill="hold" nodeType="clickEffect">
+                                  <p:stCondLst>
+                                    <p:cond delay="0"/>
+                                  </p:stCondLst>
+                                  <p:childTnLst>
+                                    <p:set>
+                                      <p:cBhvr>
+                                        <p:cTn id="22" dur="1" fill="hold">
+                                          <p:stCondLst>
+                                            <p:cond delay="0"/>
+                                          </p:stCondLst>
+                                        </p:cTn>
+                                        <p:tgtEl>
+                                          <p:spTgt spid="8">
+                                            <p:txEl>
+                                              <p:pRg st="4" end="4"/>
+                                            </p:txEl>
+                                          </p:spTgt>
+                                        </p:tgtEl>
+                                        <p:attrNameLst>
+                                          <p:attrName>style.visibility</p:attrName>
+                                        </p:attrNameLst>
+                                      </p:cBhvr>
+                                      <p:to>
+                                        <p:strVal val="visible"/>
+                                      </p:to>
+                                    </p:set>
+                                    <p:animEffect transition="in" filter="fade">
+                                      <p:cBhvr>
+                                        <p:cTn id="23" dur="500"/>
+                                        <p:tgtEl>
+                                          <p:spTgt spid="8">
+                                            <p:txEl>
+                                              <p:pRg st="4" end="4"/>
+                                            </p:txEl>
+                                          </p:spTgt>
+                                        </p:tgtEl>
+                                      </p:cBhvr>
+                                    </p:animEffect>
+                                  </p:childTnLst>
+                                </p:cTn>
+                              </p:par>
+                              <p:par>
+                                <p:cTn id="24" presetID="10" presetClass="entr" presetSubtype="0" fill="hold" nodeType="withEffect">
+                                  <p:stCondLst>
+                                    <p:cond delay="0"/>
+                                  </p:stCondLst>
+                                  <p:childTnLst>
+                                    <p:set>
+                                      <p:cBhvr>
+                                        <p:cTn id="25" dur="1" fill="hold">
+                                          <p:stCondLst>
+                                            <p:cond delay="0"/>
+                                          </p:stCondLst>
+                                        </p:cTn>
+                                        <p:tgtEl>
+                                          <p:spTgt spid="8">
+                                            <p:txEl>
+                                              <p:pRg st="5" end="5"/>
+                                            </p:txEl>
+                                          </p:spTgt>
+                                        </p:tgtEl>
+                                        <p:attrNameLst>
+                                          <p:attrName>style.visibility</p:attrName>
+                                        </p:attrNameLst>
+                                      </p:cBhvr>
+                                      <p:to>
+                                        <p:strVal val="visible"/>
+                                      </p:to>
+                                    </p:set>
+                                    <p:animEffect transition="in" filter="fade">
+                                      <p:cBhvr>
+                                        <p:cTn id="26" dur="500"/>
+                                        <p:tgtEl>
+                                          <p:spTgt spid="8">
+                                            <p:txEl>
+                                              <p:pRg st="5" end="5"/>
+                                            </p:txEl>
+                                          </p:spTgt>
+                                        </p:tgtEl>
+                                      </p:cBhvr>
+                                    </p:animEffect>
+                                  </p:childTnLst>
+                                </p:cTn>
+                              </p:par>
+                            </p:childTnLst>
+                          </p:cTn>
+                        </p:par>
+                      </p:childTnLst>
+                    </p:cTn>
+                  </p:par>
+                </p:childTnLst>
+              </p:cTn>
+              <p:prevCondLst>
+                <p:cond evt="onPrev" delay="0">
+                  <p:tgtEl>
+                    <p:sldTgt/>
+                  </p:tgtEl>
+                </p:cond>
+              </p:prevCondLst>
+              <p:nextCondLst>
+                <p:cond evt="onNext" delay="0">
+                  <p:tgtEl>
+                    <p:sldTgt/>
+                  </p:tgtEl>
+                </p:cond>
+              </p:nextCondLst>
+            </p:seq>
+          </p:childTnLst>
+        </p:cTn>
+      </p:par>
+    </p:tnLst>
+  </p:timing>
 </p:sld>
 </file>
 
@@ -11816,8 +12566,8 @@
           </a:p>
         </p:txBody>
       </p:sp>
-      <mc:AlternateContent xmlns:mc="http://schemas.openxmlformats.org/markup-compatibility/2006" xmlns:a14="http://schemas.microsoft.com/office/drawing/2010/main">
-        <mc:Choice Requires="a14">
+      <mc:AlternateContent xmlns:mc="http://schemas.openxmlformats.org/markup-compatibility/2006">
+        <mc:Choice xmlns:a14="http://schemas.microsoft.com/office/drawing/2010/main" Requires="a14">
           <p:sp>
             <p:nvSpPr>
               <p:cNvPr id="8" name="Content Placeholder 7">
@@ -11859,7 +12609,19 @@
                 </a:pPr>
                 <a:r>
                   <a:rPr lang="en-US" dirty="0"/>
-                  <a:t>Suppose our dataset U is from a simulation that depends on a set of parameters </a:t>
+                  <a:t>Suppose our dataset U of sample size </a:t>
+                </a:r>
+                <a:r>
+                  <a:rPr lang="en-US" i="1" dirty="0">
+                    <a:solidFill>
+                      <a:srgbClr val="0033CC"/>
+                    </a:solidFill>
+                  </a:rPr>
+                  <a:t>N</a:t>
+                </a:r>
+                <a:r>
+                  <a:rPr lang="en-US" dirty="0"/>
+                  <a:t> is from a simulation that depends on a set of parameters </a:t>
                 </a:r>
                 <a14:m>
                   <m:oMath xmlns:m="http://schemas.openxmlformats.org/officeDocument/2006/math">
@@ -12248,7 +13010,7 @@
             </p:txBody>
           </p:sp>
         </mc:Choice>
-        <mc:Fallback xmlns="">
+        <mc:Fallback>
           <p:sp>
             <p:nvSpPr>
               <p:cNvPr id="8" name="Content Placeholder 7">
@@ -12393,6 +13155,219 @@
       </p:transition>
     </mc:Fallback>
   </mc:AlternateContent>
+  <p:timing>
+    <p:tnLst>
+      <p:par>
+        <p:cTn id="1" dur="indefinite" restart="never" nodeType="tmRoot">
+          <p:childTnLst>
+            <p:seq concurrent="1" nextAc="seek">
+              <p:cTn id="2" dur="indefinite" nodeType="mainSeq">
+                <p:childTnLst>
+                  <p:par>
+                    <p:cTn id="3" fill="hold">
+                      <p:stCondLst>
+                        <p:cond delay="indefinite"/>
+                      </p:stCondLst>
+                      <p:childTnLst>
+                        <p:par>
+                          <p:cTn id="4" fill="hold">
+                            <p:stCondLst>
+                              <p:cond delay="0"/>
+                            </p:stCondLst>
+                            <p:childTnLst>
+                              <p:par>
+                                <p:cTn id="5" presetID="10" presetClass="entr" presetSubtype="0" fill="hold" nodeType="clickEffect">
+                                  <p:stCondLst>
+                                    <p:cond delay="0"/>
+                                  </p:stCondLst>
+                                  <p:childTnLst>
+                                    <p:set>
+                                      <p:cBhvr>
+                                        <p:cTn id="6" dur="1" fill="hold">
+                                          <p:stCondLst>
+                                            <p:cond delay="0"/>
+                                          </p:stCondLst>
+                                        </p:cTn>
+                                        <p:tgtEl>
+                                          <p:spTgt spid="8">
+                                            <p:txEl>
+                                              <p:pRg st="2" end="2"/>
+                                            </p:txEl>
+                                          </p:spTgt>
+                                        </p:tgtEl>
+                                        <p:attrNameLst>
+                                          <p:attrName>style.visibility</p:attrName>
+                                        </p:attrNameLst>
+                                      </p:cBhvr>
+                                      <p:to>
+                                        <p:strVal val="visible"/>
+                                      </p:to>
+                                    </p:set>
+                                    <p:animEffect transition="in" filter="fade">
+                                      <p:cBhvr>
+                                        <p:cTn id="7" dur="500"/>
+                                        <p:tgtEl>
+                                          <p:spTgt spid="8">
+                                            <p:txEl>
+                                              <p:pRg st="2" end="2"/>
+                                            </p:txEl>
+                                          </p:spTgt>
+                                        </p:tgtEl>
+                                      </p:cBhvr>
+                                    </p:animEffect>
+                                  </p:childTnLst>
+                                </p:cTn>
+                              </p:par>
+                            </p:childTnLst>
+                          </p:cTn>
+                        </p:par>
+                      </p:childTnLst>
+                    </p:cTn>
+                  </p:par>
+                  <p:par>
+                    <p:cTn id="8" fill="hold">
+                      <p:stCondLst>
+                        <p:cond delay="indefinite"/>
+                      </p:stCondLst>
+                      <p:childTnLst>
+                        <p:par>
+                          <p:cTn id="9" fill="hold">
+                            <p:stCondLst>
+                              <p:cond delay="0"/>
+                            </p:stCondLst>
+                            <p:childTnLst>
+                              <p:par>
+                                <p:cTn id="10" presetID="10" presetClass="entr" presetSubtype="0" fill="hold" nodeType="clickEffect">
+                                  <p:stCondLst>
+                                    <p:cond delay="0"/>
+                                  </p:stCondLst>
+                                  <p:childTnLst>
+                                    <p:set>
+                                      <p:cBhvr>
+                                        <p:cTn id="11" dur="1" fill="hold">
+                                          <p:stCondLst>
+                                            <p:cond delay="0"/>
+                                          </p:stCondLst>
+                                        </p:cTn>
+                                        <p:tgtEl>
+                                          <p:spTgt spid="8">
+                                            <p:txEl>
+                                              <p:pRg st="4" end="4"/>
+                                            </p:txEl>
+                                          </p:spTgt>
+                                        </p:tgtEl>
+                                        <p:attrNameLst>
+                                          <p:attrName>style.visibility</p:attrName>
+                                        </p:attrNameLst>
+                                      </p:cBhvr>
+                                      <p:to>
+                                        <p:strVal val="visible"/>
+                                      </p:to>
+                                    </p:set>
+                                    <p:animEffect transition="in" filter="fade">
+                                      <p:cBhvr>
+                                        <p:cTn id="12" dur="500"/>
+                                        <p:tgtEl>
+                                          <p:spTgt spid="8">
+                                            <p:txEl>
+                                              <p:pRg st="4" end="4"/>
+                                            </p:txEl>
+                                          </p:spTgt>
+                                        </p:tgtEl>
+                                      </p:cBhvr>
+                                    </p:animEffect>
+                                  </p:childTnLst>
+                                </p:cTn>
+                              </p:par>
+                            </p:childTnLst>
+                          </p:cTn>
+                        </p:par>
+                      </p:childTnLst>
+                    </p:cTn>
+                  </p:par>
+                  <p:par>
+                    <p:cTn id="13" fill="hold">
+                      <p:stCondLst>
+                        <p:cond delay="indefinite"/>
+                      </p:stCondLst>
+                      <p:childTnLst>
+                        <p:par>
+                          <p:cTn id="14" fill="hold">
+                            <p:stCondLst>
+                              <p:cond delay="0"/>
+                            </p:stCondLst>
+                            <p:childTnLst>
+                              <p:par>
+                                <p:cTn id="15" presetID="10" presetClass="entr" presetSubtype="0" fill="hold" nodeType="clickEffect">
+                                  <p:stCondLst>
+                                    <p:cond delay="0"/>
+                                  </p:stCondLst>
+                                  <p:childTnLst>
+                                    <p:set>
+                                      <p:cBhvr>
+                                        <p:cTn id="16" dur="1" fill="hold">
+                                          <p:stCondLst>
+                                            <p:cond delay="0"/>
+                                          </p:stCondLst>
+                                        </p:cTn>
+                                        <p:tgtEl>
+                                          <p:spTgt spid="8">
+                                            <p:txEl>
+                                              <p:pRg st="6" end="6"/>
+                                            </p:txEl>
+                                          </p:spTgt>
+                                        </p:tgtEl>
+                                        <p:attrNameLst>
+                                          <p:attrName>style.visibility</p:attrName>
+                                        </p:attrNameLst>
+                                      </p:cBhvr>
+                                      <p:to>
+                                        <p:strVal val="visible"/>
+                                      </p:to>
+                                    </p:set>
+                                    <p:animEffect transition="in" filter="fade">
+                                      <p:cBhvr>
+                                        <p:cTn id="17" dur="500"/>
+                                        <p:tgtEl>
+                                          <p:spTgt spid="8">
+                                            <p:txEl>
+                                              <p:pRg st="6" end="6"/>
+                                            </p:txEl>
+                                          </p:spTgt>
+                                        </p:tgtEl>
+                                      </p:cBhvr>
+                                    </p:animEffect>
+                                  </p:childTnLst>
+                                </p:cTn>
+                              </p:par>
+                            </p:childTnLst>
+                          </p:cTn>
+                        </p:par>
+                      </p:childTnLst>
+                    </p:cTn>
+                  </p:par>
+                </p:childTnLst>
+              </p:cTn>
+              <p:prevCondLst>
+                <p:cond evt="onPrev" delay="0">
+                  <p:tgtEl>
+                    <p:sldTgt/>
+                  </p:tgtEl>
+                </p:cond>
+              </p:prevCondLst>
+              <p:nextCondLst>
+                <p:cond evt="onNext" delay="0">
+                  <p:tgtEl>
+                    <p:sldTgt/>
+                  </p:tgtEl>
+                </p:cond>
+              </p:nextCondLst>
+            </p:seq>
+          </p:childTnLst>
+        </p:cTn>
+      </p:par>
+    </p:tnLst>
+  </p:timing>
 </p:sld>
 </file>
 
@@ -13493,10 +14468,1654 @@
       </p:transition>
     </mc:Fallback>
   </mc:AlternateContent>
+  <p:timing>
+    <p:tnLst>
+      <p:par>
+        <p:cTn id="1" dur="indefinite" restart="never" nodeType="tmRoot">
+          <p:childTnLst>
+            <p:seq concurrent="1" nextAc="seek">
+              <p:cTn id="2" dur="indefinite" nodeType="mainSeq">
+                <p:childTnLst>
+                  <p:par>
+                    <p:cTn id="3" fill="hold">
+                      <p:stCondLst>
+                        <p:cond delay="indefinite"/>
+                      </p:stCondLst>
+                      <p:childTnLst>
+                        <p:par>
+                          <p:cTn id="4" fill="hold">
+                            <p:stCondLst>
+                              <p:cond delay="0"/>
+                            </p:stCondLst>
+                            <p:childTnLst>
+                              <p:par>
+                                <p:cTn id="5" presetID="10" presetClass="entr" presetSubtype="0" fill="hold" nodeType="clickEffect">
+                                  <p:stCondLst>
+                                    <p:cond delay="0"/>
+                                  </p:stCondLst>
+                                  <p:childTnLst>
+                                    <p:set>
+                                      <p:cBhvr>
+                                        <p:cTn id="6" dur="1" fill="hold">
+                                          <p:stCondLst>
+                                            <p:cond delay="0"/>
+                                          </p:stCondLst>
+                                        </p:cTn>
+                                        <p:tgtEl>
+                                          <p:spTgt spid="8">
+                                            <p:txEl>
+                                              <p:pRg st="2" end="2"/>
+                                            </p:txEl>
+                                          </p:spTgt>
+                                        </p:tgtEl>
+                                        <p:attrNameLst>
+                                          <p:attrName>style.visibility</p:attrName>
+                                        </p:attrNameLst>
+                                      </p:cBhvr>
+                                      <p:to>
+                                        <p:strVal val="visible"/>
+                                      </p:to>
+                                    </p:set>
+                                    <p:animEffect transition="in" filter="fade">
+                                      <p:cBhvr>
+                                        <p:cTn id="7" dur="500"/>
+                                        <p:tgtEl>
+                                          <p:spTgt spid="8">
+                                            <p:txEl>
+                                              <p:pRg st="2" end="2"/>
+                                            </p:txEl>
+                                          </p:spTgt>
+                                        </p:tgtEl>
+                                      </p:cBhvr>
+                                    </p:animEffect>
+                                  </p:childTnLst>
+                                </p:cTn>
+                              </p:par>
+                            </p:childTnLst>
+                          </p:cTn>
+                        </p:par>
+                      </p:childTnLst>
+                    </p:cTn>
+                  </p:par>
+                  <p:par>
+                    <p:cTn id="8" fill="hold">
+                      <p:stCondLst>
+                        <p:cond delay="indefinite"/>
+                      </p:stCondLst>
+                      <p:childTnLst>
+                        <p:par>
+                          <p:cTn id="9" fill="hold">
+                            <p:stCondLst>
+                              <p:cond delay="0"/>
+                            </p:stCondLst>
+                            <p:childTnLst>
+                              <p:par>
+                                <p:cTn id="10" presetID="10" presetClass="entr" presetSubtype="0" fill="hold" nodeType="clickEffect">
+                                  <p:stCondLst>
+                                    <p:cond delay="0"/>
+                                  </p:stCondLst>
+                                  <p:childTnLst>
+                                    <p:set>
+                                      <p:cBhvr>
+                                        <p:cTn id="11" dur="1" fill="hold">
+                                          <p:stCondLst>
+                                            <p:cond delay="0"/>
+                                          </p:stCondLst>
+                                        </p:cTn>
+                                        <p:tgtEl>
+                                          <p:spTgt spid="8">
+                                            <p:txEl>
+                                              <p:pRg st="3" end="3"/>
+                                            </p:txEl>
+                                          </p:spTgt>
+                                        </p:tgtEl>
+                                        <p:attrNameLst>
+                                          <p:attrName>style.visibility</p:attrName>
+                                        </p:attrNameLst>
+                                      </p:cBhvr>
+                                      <p:to>
+                                        <p:strVal val="visible"/>
+                                      </p:to>
+                                    </p:set>
+                                    <p:animEffect transition="in" filter="fade">
+                                      <p:cBhvr>
+                                        <p:cTn id="12" dur="500"/>
+                                        <p:tgtEl>
+                                          <p:spTgt spid="8">
+                                            <p:txEl>
+                                              <p:pRg st="3" end="3"/>
+                                            </p:txEl>
+                                          </p:spTgt>
+                                        </p:tgtEl>
+                                      </p:cBhvr>
+                                    </p:animEffect>
+                                  </p:childTnLst>
+                                </p:cTn>
+                              </p:par>
+                            </p:childTnLst>
+                          </p:cTn>
+                        </p:par>
+                      </p:childTnLst>
+                    </p:cTn>
+                  </p:par>
+                  <p:par>
+                    <p:cTn id="13" fill="hold">
+                      <p:stCondLst>
+                        <p:cond delay="indefinite"/>
+                      </p:stCondLst>
+                      <p:childTnLst>
+                        <p:par>
+                          <p:cTn id="14" fill="hold">
+                            <p:stCondLst>
+                              <p:cond delay="0"/>
+                            </p:stCondLst>
+                            <p:childTnLst>
+                              <p:par>
+                                <p:cTn id="15" presetID="10" presetClass="entr" presetSubtype="0" fill="hold" nodeType="clickEffect">
+                                  <p:stCondLst>
+                                    <p:cond delay="0"/>
+                                  </p:stCondLst>
+                                  <p:childTnLst>
+                                    <p:set>
+                                      <p:cBhvr>
+                                        <p:cTn id="16" dur="1" fill="hold">
+                                          <p:stCondLst>
+                                            <p:cond delay="0"/>
+                                          </p:stCondLst>
+                                        </p:cTn>
+                                        <p:tgtEl>
+                                          <p:spTgt spid="8">
+                                            <p:txEl>
+                                              <p:pRg st="4" end="4"/>
+                                            </p:txEl>
+                                          </p:spTgt>
+                                        </p:tgtEl>
+                                        <p:attrNameLst>
+                                          <p:attrName>style.visibility</p:attrName>
+                                        </p:attrNameLst>
+                                      </p:cBhvr>
+                                      <p:to>
+                                        <p:strVal val="visible"/>
+                                      </p:to>
+                                    </p:set>
+                                    <p:animEffect transition="in" filter="fade">
+                                      <p:cBhvr>
+                                        <p:cTn id="17" dur="500"/>
+                                        <p:tgtEl>
+                                          <p:spTgt spid="8">
+                                            <p:txEl>
+                                              <p:pRg st="4" end="4"/>
+                                            </p:txEl>
+                                          </p:spTgt>
+                                        </p:tgtEl>
+                                      </p:cBhvr>
+                                    </p:animEffect>
+                                  </p:childTnLst>
+                                </p:cTn>
+                              </p:par>
+                              <p:par>
+                                <p:cTn id="18" presetID="10" presetClass="entr" presetSubtype="0" fill="hold" nodeType="withEffect">
+                                  <p:stCondLst>
+                                    <p:cond delay="0"/>
+                                  </p:stCondLst>
+                                  <p:childTnLst>
+                                    <p:set>
+                                      <p:cBhvr>
+                                        <p:cTn id="19" dur="1" fill="hold">
+                                          <p:stCondLst>
+                                            <p:cond delay="0"/>
+                                          </p:stCondLst>
+                                        </p:cTn>
+                                        <p:tgtEl>
+                                          <p:spTgt spid="8">
+                                            <p:txEl>
+                                              <p:pRg st="5" end="5"/>
+                                            </p:txEl>
+                                          </p:spTgt>
+                                        </p:tgtEl>
+                                        <p:attrNameLst>
+                                          <p:attrName>style.visibility</p:attrName>
+                                        </p:attrNameLst>
+                                      </p:cBhvr>
+                                      <p:to>
+                                        <p:strVal val="visible"/>
+                                      </p:to>
+                                    </p:set>
+                                    <p:animEffect transition="in" filter="fade">
+                                      <p:cBhvr>
+                                        <p:cTn id="20" dur="500"/>
+                                        <p:tgtEl>
+                                          <p:spTgt spid="8">
+                                            <p:txEl>
+                                              <p:pRg st="5" end="5"/>
+                                            </p:txEl>
+                                          </p:spTgt>
+                                        </p:tgtEl>
+                                      </p:cBhvr>
+                                    </p:animEffect>
+                                  </p:childTnLst>
+                                </p:cTn>
+                              </p:par>
+                            </p:childTnLst>
+                          </p:cTn>
+                        </p:par>
+                      </p:childTnLst>
+                    </p:cTn>
+                  </p:par>
+                </p:childTnLst>
+              </p:cTn>
+              <p:prevCondLst>
+                <p:cond evt="onPrev" delay="0">
+                  <p:tgtEl>
+                    <p:sldTgt/>
+                  </p:tgtEl>
+                </p:cond>
+              </p:prevCondLst>
+              <p:nextCondLst>
+                <p:cond evt="onNext" delay="0">
+                  <p:tgtEl>
+                    <p:sldTgt/>
+                  </p:tgtEl>
+                </p:cond>
+              </p:nextCondLst>
+            </p:seq>
+          </p:childTnLst>
+        </p:cTn>
+      </p:par>
+    </p:tnLst>
+  </p:timing>
 </p:sld>
 </file>
 
 <file path=ppt/slides/slide25.xml><?xml version="1.0" encoding="utf-8"?>
+<p:sld xmlns:a="http://schemas.openxmlformats.org/drawingml/2006/main" xmlns:r="http://schemas.openxmlformats.org/officeDocument/2006/relationships" xmlns:p="http://schemas.openxmlformats.org/presentationml/2006/main">
+  <p:cSld>
+    <p:spTree>
+      <p:nvGrpSpPr>
+        <p:cNvPr id="1" name="">
+          <a:extLst>
+            <a:ext uri="{FF2B5EF4-FFF2-40B4-BE49-F238E27FC236}">
+              <a16:creationId xmlns:a16="http://schemas.microsoft.com/office/drawing/2014/main" id="{7D044B2E-2CA7-ACE0-1259-9EEEF9EAC374}"/>
+            </a:ext>
+          </a:extLst>
+        </p:cNvPr>
+        <p:cNvGrpSpPr/>
+        <p:nvPr/>
+      </p:nvGrpSpPr>
+      <p:grpSpPr>
+        <a:xfrm>
+          <a:off x="0" y="0"/>
+          <a:ext cx="0" cy="0"/>
+          <a:chOff x="0" y="0"/>
+          <a:chExt cx="0" cy="0"/>
+        </a:xfrm>
+      </p:grpSpPr>
+      <p:sp>
+        <p:nvSpPr>
+          <p:cNvPr id="7" name="Title 6">
+            <a:extLst>
+              <a:ext uri="{FF2B5EF4-FFF2-40B4-BE49-F238E27FC236}">
+                <a16:creationId xmlns:a16="http://schemas.microsoft.com/office/drawing/2014/main" id="{BC248160-7434-7564-BA6D-B92669462A2C}"/>
+              </a:ext>
+            </a:extLst>
+          </p:cNvPr>
+          <p:cNvSpPr>
+            <a:spLocks noGrp="1"/>
+          </p:cNvSpPr>
+          <p:nvPr>
+            <p:ph type="title"/>
+          </p:nvPr>
+        </p:nvSpPr>
+        <p:spPr/>
+        <p:txBody>
+          <a:bodyPr/>
+          <a:lstStyle/>
+          <a:p>
+            <a:r>
+              <a:rPr lang="en-US" dirty="0"/>
+              <a:t>Beyond Classification (5)</a:t>
+            </a:r>
+            <a:endParaRPr lang="en-US" dirty="0">
+              <a:solidFill>
+                <a:schemeClr val="accent1"/>
+              </a:solidFill>
+            </a:endParaRPr>
+          </a:p>
+        </p:txBody>
+      </p:sp>
+      <mc:AlternateContent xmlns:mc="http://schemas.openxmlformats.org/markup-compatibility/2006">
+        <mc:Choice xmlns:a14="http://schemas.microsoft.com/office/drawing/2010/main" Requires="a14">
+          <p:sp>
+            <p:nvSpPr>
+              <p:cNvPr id="8" name="Content Placeholder 7">
+                <a:extLst>
+                  <a:ext uri="{FF2B5EF4-FFF2-40B4-BE49-F238E27FC236}">
+                    <a16:creationId xmlns:a16="http://schemas.microsoft.com/office/drawing/2014/main" id="{67A66908-D4A5-D232-6893-666E46FDB5E0}"/>
+                  </a:ext>
+                </a:extLst>
+              </p:cNvPr>
+              <p:cNvSpPr>
+                <a:spLocks noGrp="1"/>
+              </p:cNvSpPr>
+              <p:nvPr>
+                <p:ph idx="1"/>
+              </p:nvPr>
+            </p:nvSpPr>
+            <p:spPr>
+              <a:xfrm>
+                <a:off x="711200" y="1295400"/>
+                <a:ext cx="7899400" cy="4819650"/>
+              </a:xfrm>
+            </p:spPr>
+            <p:txBody>
+              <a:bodyPr/>
+              <a:lstStyle/>
+              <a:p>
+                <a:pPr marL="0" indent="0">
+                  <a:buNone/>
+                </a:pPr>
+                <a:r>
+                  <a:rPr lang="en-US" dirty="0"/>
+                  <a:t>The ratio </a:t>
+                </a:r>
+                <a:endParaRPr lang="en-US" i="1" dirty="0">
+                  <a:latin typeface="Cambria Math" panose="02040503050406030204" pitchFamily="18" charset="0"/>
+                </a:endParaRPr>
+              </a:p>
+              <a:p>
+                <a:pPr marL="0" indent="0">
+                  <a:buNone/>
+                </a:pPr>
+                <a14:m>
+                  <m:oMathPara xmlns:m="http://schemas.openxmlformats.org/officeDocument/2006/math">
+                    <m:oMathParaPr>
+                      <m:jc m:val="centerGroup"/>
+                    </m:oMathParaPr>
+                    <m:oMath xmlns:m="http://schemas.openxmlformats.org/officeDocument/2006/math">
+                      <m:f>
+                        <m:fPr>
+                          <m:ctrlPr>
+                            <a:rPr lang="en-US" i="1">
+                              <a:latin typeface="Cambria Math" panose="02040503050406030204" pitchFamily="18" charset="0"/>
+                            </a:rPr>
+                          </m:ctrlPr>
+                        </m:fPr>
+                        <m:num>
+                          <m:r>
+                            <a:rPr lang="en-US" i="1">
+                              <a:latin typeface="Cambria Math" panose="02040503050406030204" pitchFamily="18" charset="0"/>
+                            </a:rPr>
+                            <m:t>𝐷</m:t>
+                          </m:r>
+                          <m:d>
+                            <m:dPr>
+                              <m:ctrlPr>
+                                <a:rPr lang="en-US" i="1">
+                                  <a:latin typeface="Cambria Math" panose="02040503050406030204" pitchFamily="18" charset="0"/>
+                                </a:rPr>
+                              </m:ctrlPr>
+                            </m:dPr>
+                            <m:e>
+                              <m:r>
+                                <a:rPr lang="en-US" i="1">
+                                  <a:latin typeface="Cambria Math" panose="02040503050406030204" pitchFamily="18" charset="0"/>
+                                </a:rPr>
+                                <m:t>𝑥</m:t>
+                              </m:r>
+                              <m:r>
+                                <a:rPr lang="en-US" i="1">
+                                  <a:latin typeface="Cambria Math" panose="02040503050406030204" pitchFamily="18" charset="0"/>
+                                </a:rPr>
+                                <m:t>, </m:t>
+                              </m:r>
+                              <m:r>
+                                <a:rPr lang="en-US" i="1">
+                                  <a:latin typeface="Cambria Math" panose="02040503050406030204" pitchFamily="18" charset="0"/>
+                                </a:rPr>
+                                <m:t>𝜃</m:t>
+                              </m:r>
+                            </m:e>
+                          </m:d>
+                        </m:num>
+                        <m:den>
+                          <m:r>
+                            <a:rPr lang="en-US" i="1">
+                              <a:latin typeface="Cambria Math" panose="02040503050406030204" pitchFamily="18" charset="0"/>
+                            </a:rPr>
+                            <m:t>1−</m:t>
+                          </m:r>
+                          <m:r>
+                            <a:rPr lang="en-US" i="1">
+                              <a:latin typeface="Cambria Math" panose="02040503050406030204" pitchFamily="18" charset="0"/>
+                            </a:rPr>
+                            <m:t>𝐷</m:t>
+                          </m:r>
+                          <m:d>
+                            <m:dPr>
+                              <m:ctrlPr>
+                                <a:rPr lang="en-US" i="1">
+                                  <a:latin typeface="Cambria Math" panose="02040503050406030204" pitchFamily="18" charset="0"/>
+                                </a:rPr>
+                              </m:ctrlPr>
+                            </m:dPr>
+                            <m:e>
+                              <m:r>
+                                <a:rPr lang="en-US" i="1">
+                                  <a:latin typeface="Cambria Math" panose="02040503050406030204" pitchFamily="18" charset="0"/>
+                                </a:rPr>
+                                <m:t>𝑥</m:t>
+                              </m:r>
+                              <m:r>
+                                <a:rPr lang="en-US" i="1">
+                                  <a:latin typeface="Cambria Math" panose="02040503050406030204" pitchFamily="18" charset="0"/>
+                                </a:rPr>
+                                <m:t>, </m:t>
+                              </m:r>
+                              <m:r>
+                                <a:rPr lang="en-US" i="1">
+                                  <a:latin typeface="Cambria Math" panose="02040503050406030204" pitchFamily="18" charset="0"/>
+                                </a:rPr>
+                                <m:t>𝜃</m:t>
+                              </m:r>
+                            </m:e>
+                          </m:d>
+                        </m:den>
+                      </m:f>
+                    </m:oMath>
+                  </m:oMathPara>
+                </a14:m>
+                <a:endParaRPr lang="en-US" dirty="0"/>
+              </a:p>
+              <a:p>
+                <a:pPr marL="0" indent="0">
+                  <a:buNone/>
+                </a:pPr>
+                <a:r>
+                  <a:rPr lang="en-US" dirty="0"/>
+                  <a:t>could have a large dynamic range. </a:t>
+                </a:r>
+              </a:p>
+              <a:p>
+                <a:pPr marL="0" indent="0">
+                  <a:buNone/>
+                </a:pPr>
+                <a:r>
+                  <a:rPr lang="en-US" dirty="0"/>
+                  <a:t>If so,  instead of approximating </a:t>
+                </a:r>
+                <a14:m>
+                  <m:oMath xmlns:m="http://schemas.openxmlformats.org/officeDocument/2006/math">
+                    <m:r>
+                      <a:rPr lang="en-US" i="1" smtClean="0">
+                        <a:solidFill>
+                          <a:srgbClr val="0033CC"/>
+                        </a:solidFill>
+                        <a:latin typeface="Cambria Math" panose="02040503050406030204" pitchFamily="18" charset="0"/>
+                      </a:rPr>
+                      <m:t>𝐷</m:t>
+                    </m:r>
+                    <m:d>
+                      <m:dPr>
+                        <m:ctrlPr>
+                          <a:rPr lang="en-US" i="1">
+                            <a:solidFill>
+                              <a:srgbClr val="0033CC"/>
+                            </a:solidFill>
+                            <a:latin typeface="Cambria Math" panose="02040503050406030204" pitchFamily="18" charset="0"/>
+                          </a:rPr>
+                        </m:ctrlPr>
+                      </m:dPr>
+                      <m:e>
+                        <m:r>
+                          <a:rPr lang="en-US" i="1">
+                            <a:solidFill>
+                              <a:srgbClr val="0033CC"/>
+                            </a:solidFill>
+                            <a:latin typeface="Cambria Math" panose="02040503050406030204" pitchFamily="18" charset="0"/>
+                          </a:rPr>
+                          <m:t>𝑥</m:t>
+                        </m:r>
+                        <m:r>
+                          <a:rPr lang="en-US" i="1">
+                            <a:solidFill>
+                              <a:srgbClr val="0033CC"/>
+                            </a:solidFill>
+                            <a:latin typeface="Cambria Math" panose="02040503050406030204" pitchFamily="18" charset="0"/>
+                          </a:rPr>
+                          <m:t>, </m:t>
+                        </m:r>
+                        <m:r>
+                          <a:rPr lang="en-US" i="1">
+                            <a:solidFill>
+                              <a:srgbClr val="0033CC"/>
+                            </a:solidFill>
+                            <a:latin typeface="Cambria Math" panose="02040503050406030204" pitchFamily="18" charset="0"/>
+                          </a:rPr>
+                          <m:t>𝜃</m:t>
+                        </m:r>
+                      </m:e>
+                    </m:d>
+                  </m:oMath>
+                </a14:m>
+                <a:r>
+                  <a:rPr lang="en-US" dirty="0"/>
+                  <a:t>, it may be better to use the appropriate* loss function to approximate </a:t>
+                </a:r>
+              </a:p>
+              <a:p>
+                <a:pPr marL="0" indent="0">
+                  <a:buNone/>
+                </a:pPr>
+                <a14:m>
+                  <m:oMathPara xmlns:m="http://schemas.openxmlformats.org/officeDocument/2006/math">
+                    <m:oMathParaPr>
+                      <m:jc m:val="centerGroup"/>
+                    </m:oMathParaPr>
+                    <m:oMath xmlns:m="http://schemas.openxmlformats.org/officeDocument/2006/math">
+                      <m:r>
+                        <a:rPr lang="en-US" b="0" i="1" smtClean="0">
+                          <a:latin typeface="Cambria Math" panose="02040503050406030204" pitchFamily="18" charset="0"/>
+                        </a:rPr>
+                        <m:t>𝑓</m:t>
+                      </m:r>
+                      <m:d>
+                        <m:dPr>
+                          <m:ctrlPr>
+                            <a:rPr lang="en-US" b="0" i="1" smtClean="0">
+                              <a:latin typeface="Cambria Math" panose="02040503050406030204" pitchFamily="18" charset="0"/>
+                            </a:rPr>
+                          </m:ctrlPr>
+                        </m:dPr>
+                        <m:e>
+                          <m:r>
+                            <a:rPr lang="en-US" b="0" i="1" smtClean="0">
+                              <a:latin typeface="Cambria Math" panose="02040503050406030204" pitchFamily="18" charset="0"/>
+                            </a:rPr>
+                            <m:t>𝑥</m:t>
+                          </m:r>
+                          <m:r>
+                            <a:rPr lang="en-US" b="0" i="1" smtClean="0">
+                              <a:latin typeface="Cambria Math" panose="02040503050406030204" pitchFamily="18" charset="0"/>
+                            </a:rPr>
+                            <m:t>, </m:t>
+                          </m:r>
+                          <m:r>
+                            <a:rPr lang="en-US" b="0" i="1" smtClean="0">
+                              <a:latin typeface="Cambria Math" panose="02040503050406030204" pitchFamily="18" charset="0"/>
+                            </a:rPr>
+                            <m:t>𝜃</m:t>
+                          </m:r>
+                        </m:e>
+                      </m:d>
+                      <m:r>
+                        <a:rPr lang="en-US" b="0" i="1" smtClean="0">
+                          <a:latin typeface="Cambria Math" panose="02040503050406030204" pitchFamily="18" charset="0"/>
+                        </a:rPr>
+                        <m:t>=</m:t>
+                      </m:r>
+                      <m:func>
+                        <m:funcPr>
+                          <m:ctrlPr>
+                            <a:rPr lang="en-US" b="0" i="1" smtClean="0">
+                              <a:latin typeface="Cambria Math" panose="02040503050406030204" pitchFamily="18" charset="0"/>
+                            </a:rPr>
+                          </m:ctrlPr>
+                        </m:funcPr>
+                        <m:fName>
+                          <m:r>
+                            <m:rPr>
+                              <m:sty m:val="p"/>
+                            </m:rPr>
+                            <a:rPr lang="en-US" b="0" i="0" smtClean="0">
+                              <a:latin typeface="Cambria Math" panose="02040503050406030204" pitchFamily="18" charset="0"/>
+                            </a:rPr>
+                            <m:t>log</m:t>
+                          </m:r>
+                        </m:fName>
+                        <m:e>
+                          <m:d>
+                            <m:dPr>
+                              <m:begChr m:val="["/>
+                              <m:endChr m:val="]"/>
+                              <m:ctrlPr>
+                                <a:rPr lang="en-US" i="1">
+                                  <a:latin typeface="Cambria Math" panose="02040503050406030204" pitchFamily="18" charset="0"/>
+                                </a:rPr>
+                              </m:ctrlPr>
+                            </m:dPr>
+                            <m:e>
+                              <m:f>
+                                <m:fPr>
+                                  <m:ctrlPr>
+                                    <a:rPr lang="en-US" i="1">
+                                      <a:latin typeface="Cambria Math" panose="02040503050406030204" pitchFamily="18" charset="0"/>
+                                    </a:rPr>
+                                  </m:ctrlPr>
+                                </m:fPr>
+                                <m:num>
+                                  <m:r>
+                                    <a:rPr lang="en-US" i="1">
+                                      <a:latin typeface="Cambria Math" panose="02040503050406030204" pitchFamily="18" charset="0"/>
+                                    </a:rPr>
+                                    <m:t>𝐷</m:t>
+                                  </m:r>
+                                  <m:d>
+                                    <m:dPr>
+                                      <m:ctrlPr>
+                                        <a:rPr lang="en-US" i="1">
+                                          <a:latin typeface="Cambria Math" panose="02040503050406030204" pitchFamily="18" charset="0"/>
+                                        </a:rPr>
+                                      </m:ctrlPr>
+                                    </m:dPr>
+                                    <m:e>
+                                      <m:r>
+                                        <a:rPr lang="en-US" i="1">
+                                          <a:latin typeface="Cambria Math" panose="02040503050406030204" pitchFamily="18" charset="0"/>
+                                        </a:rPr>
+                                        <m:t>𝑥</m:t>
+                                      </m:r>
+                                      <m:r>
+                                        <a:rPr lang="en-US" i="1">
+                                          <a:latin typeface="Cambria Math" panose="02040503050406030204" pitchFamily="18" charset="0"/>
+                                        </a:rPr>
+                                        <m:t>, </m:t>
+                                      </m:r>
+                                      <m:r>
+                                        <a:rPr lang="en-US" i="1">
+                                          <a:latin typeface="Cambria Math" panose="02040503050406030204" pitchFamily="18" charset="0"/>
+                                        </a:rPr>
+                                        <m:t>𝜃</m:t>
+                                      </m:r>
+                                    </m:e>
+                                  </m:d>
+                                </m:num>
+                                <m:den>
+                                  <m:r>
+                                    <a:rPr lang="en-US" i="1">
+                                      <a:latin typeface="Cambria Math" panose="02040503050406030204" pitchFamily="18" charset="0"/>
+                                    </a:rPr>
+                                    <m:t>1−</m:t>
+                                  </m:r>
+                                  <m:r>
+                                    <a:rPr lang="en-US" i="1">
+                                      <a:latin typeface="Cambria Math" panose="02040503050406030204" pitchFamily="18" charset="0"/>
+                                    </a:rPr>
+                                    <m:t>𝐷</m:t>
+                                  </m:r>
+                                  <m:d>
+                                    <m:dPr>
+                                      <m:ctrlPr>
+                                        <a:rPr lang="en-US" i="1">
+                                          <a:latin typeface="Cambria Math" panose="02040503050406030204" pitchFamily="18" charset="0"/>
+                                        </a:rPr>
+                                      </m:ctrlPr>
+                                    </m:dPr>
+                                    <m:e>
+                                      <m:r>
+                                        <a:rPr lang="en-US" i="1">
+                                          <a:latin typeface="Cambria Math" panose="02040503050406030204" pitchFamily="18" charset="0"/>
+                                        </a:rPr>
+                                        <m:t>𝑥</m:t>
+                                      </m:r>
+                                      <m:r>
+                                        <a:rPr lang="en-US" i="1">
+                                          <a:latin typeface="Cambria Math" panose="02040503050406030204" pitchFamily="18" charset="0"/>
+                                        </a:rPr>
+                                        <m:t>, </m:t>
+                                      </m:r>
+                                      <m:r>
+                                        <a:rPr lang="en-US" i="1">
+                                          <a:latin typeface="Cambria Math" panose="02040503050406030204" pitchFamily="18" charset="0"/>
+                                        </a:rPr>
+                                        <m:t>𝜃</m:t>
+                                      </m:r>
+                                    </m:e>
+                                  </m:d>
+                                </m:den>
+                              </m:f>
+                            </m:e>
+                          </m:d>
+                        </m:e>
+                      </m:func>
+                    </m:oMath>
+                  </m:oMathPara>
+                </a14:m>
+                <a:endParaRPr lang="en-US" dirty="0"/>
+              </a:p>
+              <a:p>
+                <a:pPr marL="0" indent="0">
+                  <a:buNone/>
+                </a:pPr>
+                <a:r>
+                  <a:rPr lang="en-US" dirty="0"/>
+                  <a:t>and then compute </a:t>
+                </a:r>
+                <a:endParaRPr lang="en-US" i="1" dirty="0">
+                  <a:latin typeface="Cambria Math" panose="02040503050406030204" pitchFamily="18" charset="0"/>
+                </a:endParaRPr>
+              </a:p>
+              <a:p>
+                <a:pPr marL="0" indent="0">
+                  <a:buNone/>
+                </a:pPr>
+                <a14:m>
+                  <m:oMathPara xmlns:m="http://schemas.openxmlformats.org/officeDocument/2006/math">
+                    <m:oMathParaPr>
+                      <m:jc m:val="centerGroup"/>
+                    </m:oMathParaPr>
+                    <m:oMath xmlns:m="http://schemas.openxmlformats.org/officeDocument/2006/math">
+                      <m:func>
+                        <m:funcPr>
+                          <m:ctrlPr>
+                            <a:rPr lang="en-US" b="0" i="1" smtClean="0">
+                              <a:solidFill>
+                                <a:schemeClr val="tx1"/>
+                              </a:solidFill>
+                              <a:latin typeface="Cambria Math" panose="02040503050406030204" pitchFamily="18" charset="0"/>
+                            </a:rPr>
+                          </m:ctrlPr>
+                        </m:funcPr>
+                        <m:fName>
+                          <m:r>
+                            <m:rPr>
+                              <m:sty m:val="p"/>
+                            </m:rPr>
+                            <a:rPr lang="en-US" b="0" i="0" smtClean="0">
+                              <a:solidFill>
+                                <a:schemeClr val="tx1"/>
+                              </a:solidFill>
+                              <a:latin typeface="Cambria Math" panose="02040503050406030204" pitchFamily="18" charset="0"/>
+                            </a:rPr>
+                            <m:t>log</m:t>
+                          </m:r>
+                        </m:fName>
+                        <m:e>
+                          <m:r>
+                            <a:rPr lang="en-US" i="1">
+                              <a:solidFill>
+                                <a:schemeClr val="tx1"/>
+                              </a:solidFill>
+                              <a:latin typeface="Cambria Math" panose="02040503050406030204" pitchFamily="18" charset="0"/>
+                            </a:rPr>
+                            <m:t>𝑢</m:t>
+                          </m:r>
+                          <m:d>
+                            <m:dPr>
+                              <m:ctrlPr>
+                                <a:rPr lang="en-US" i="1">
+                                  <a:solidFill>
+                                    <a:schemeClr val="tx1"/>
+                                  </a:solidFill>
+                                  <a:latin typeface="Cambria Math" panose="02040503050406030204" pitchFamily="18" charset="0"/>
+                                </a:rPr>
+                              </m:ctrlPr>
+                            </m:dPr>
+                            <m:e>
+                              <m:r>
+                                <a:rPr lang="en-US" i="1">
+                                  <a:solidFill>
+                                    <a:schemeClr val="tx1"/>
+                                  </a:solidFill>
+                                  <a:latin typeface="Cambria Math" panose="02040503050406030204" pitchFamily="18" charset="0"/>
+                                </a:rPr>
+                                <m:t>𝑥</m:t>
+                              </m:r>
+                              <m:r>
+                                <a:rPr lang="en-US" b="0" i="1" smtClean="0">
+                                  <a:solidFill>
+                                    <a:schemeClr val="tx1"/>
+                                  </a:solidFill>
+                                  <a:latin typeface="Cambria Math" panose="02040503050406030204" pitchFamily="18" charset="0"/>
+                                </a:rPr>
+                                <m:t>, </m:t>
+                              </m:r>
+                              <m:r>
+                                <a:rPr lang="en-US" i="1">
+                                  <a:solidFill>
+                                    <a:schemeClr val="tx1"/>
+                                  </a:solidFill>
+                                  <a:latin typeface="Cambria Math" panose="02040503050406030204" pitchFamily="18" charset="0"/>
+                                </a:rPr>
+                                <m:t>𝜃</m:t>
+                              </m:r>
+                            </m:e>
+                          </m:d>
+                          <m:r>
+                            <m:rPr>
+                              <m:aln/>
+                            </m:rPr>
+                            <a:rPr lang="en-US" b="0" i="1" smtClean="0">
+                              <a:solidFill>
+                                <a:schemeClr val="tx1"/>
+                              </a:solidFill>
+                              <a:latin typeface="Cambria Math" panose="02040503050406030204" pitchFamily="18" charset="0"/>
+                            </a:rPr>
+                            <m:t>=</m:t>
+                          </m:r>
+                        </m:e>
+                      </m:func>
+                      <m:func>
+                        <m:funcPr>
+                          <m:ctrlPr>
+                            <a:rPr lang="en-US" b="0" i="1" smtClean="0">
+                              <a:solidFill>
+                                <a:schemeClr val="tx1"/>
+                              </a:solidFill>
+                              <a:latin typeface="Cambria Math" panose="02040503050406030204" pitchFamily="18" charset="0"/>
+                            </a:rPr>
+                          </m:ctrlPr>
+                        </m:funcPr>
+                        <m:fName>
+                          <m:r>
+                            <m:rPr>
+                              <m:sty m:val="p"/>
+                            </m:rPr>
+                            <a:rPr lang="en-US" b="0" i="0" smtClean="0">
+                              <a:solidFill>
+                                <a:schemeClr val="tx1"/>
+                              </a:solidFill>
+                              <a:latin typeface="Cambria Math" panose="02040503050406030204" pitchFamily="18" charset="0"/>
+                            </a:rPr>
+                            <m:t>log</m:t>
+                          </m:r>
+                        </m:fName>
+                        <m:e>
+                          <m:r>
+                            <a:rPr lang="en-US" i="1">
+                              <a:solidFill>
+                                <a:schemeClr val="tx1"/>
+                              </a:solidFill>
+                              <a:latin typeface="Cambria Math" panose="02040503050406030204" pitchFamily="18" charset="0"/>
+                            </a:rPr>
+                            <m:t>𝑘</m:t>
+                          </m:r>
+                          <m:d>
+                            <m:dPr>
+                              <m:ctrlPr>
+                                <a:rPr lang="en-US" i="1">
+                                  <a:solidFill>
+                                    <a:schemeClr val="tx1"/>
+                                  </a:solidFill>
+                                  <a:latin typeface="Cambria Math" panose="02040503050406030204" pitchFamily="18" charset="0"/>
+                                </a:rPr>
+                              </m:ctrlPr>
+                            </m:dPr>
+                            <m:e>
+                              <m:r>
+                                <a:rPr lang="en-US" i="1">
+                                  <a:solidFill>
+                                    <a:schemeClr val="tx1"/>
+                                  </a:solidFill>
+                                  <a:latin typeface="Cambria Math" panose="02040503050406030204" pitchFamily="18" charset="0"/>
+                                </a:rPr>
+                                <m:t>𝑥</m:t>
+                              </m:r>
+                            </m:e>
+                            <m:e>
+                              <m:r>
+                                <a:rPr lang="en-US" i="1">
+                                  <a:solidFill>
+                                    <a:schemeClr val="tx1"/>
+                                  </a:solidFill>
+                                  <a:latin typeface="Cambria Math" panose="02040503050406030204" pitchFamily="18" charset="0"/>
+                                </a:rPr>
+                                <m:t>𝜃</m:t>
+                              </m:r>
+                            </m:e>
+                          </m:d>
+                        </m:e>
+                      </m:func>
+                      <m:r>
+                        <a:rPr lang="en-US" b="0" i="1" smtClean="0">
+                          <a:solidFill>
+                            <a:schemeClr val="tx1"/>
+                          </a:solidFill>
+                          <a:latin typeface="Cambria Math" panose="02040503050406030204" pitchFamily="18" charset="0"/>
+                        </a:rPr>
+                        <m:t>+ </m:t>
+                      </m:r>
+                      <m:func>
+                        <m:funcPr>
+                          <m:ctrlPr>
+                            <a:rPr lang="en-US" b="0" i="1" smtClean="0">
+                              <a:solidFill>
+                                <a:schemeClr val="tx1"/>
+                              </a:solidFill>
+                              <a:latin typeface="Cambria Math" panose="02040503050406030204" pitchFamily="18" charset="0"/>
+                            </a:rPr>
+                          </m:ctrlPr>
+                        </m:funcPr>
+                        <m:fName>
+                          <m:r>
+                            <m:rPr>
+                              <m:sty m:val="p"/>
+                            </m:rPr>
+                            <a:rPr lang="en-US" b="0" i="0" smtClean="0">
+                              <a:solidFill>
+                                <a:schemeClr val="tx1"/>
+                              </a:solidFill>
+                              <a:latin typeface="Cambria Math" panose="02040503050406030204" pitchFamily="18" charset="0"/>
+                            </a:rPr>
+                            <m:t>log</m:t>
+                          </m:r>
+                        </m:fName>
+                        <m:e>
+                          <m:r>
+                            <a:rPr lang="en-US" i="1">
+                              <a:solidFill>
+                                <a:schemeClr val="tx1"/>
+                              </a:solidFill>
+                              <a:latin typeface="Cambria Math" panose="02040503050406030204" pitchFamily="18" charset="0"/>
+                            </a:rPr>
+                            <m:t>𝜋</m:t>
+                          </m:r>
+                          <m:d>
+                            <m:dPr>
+                              <m:ctrlPr>
+                                <a:rPr lang="en-US" i="1">
+                                  <a:solidFill>
+                                    <a:schemeClr val="tx1"/>
+                                  </a:solidFill>
+                                  <a:latin typeface="Cambria Math" panose="02040503050406030204" pitchFamily="18" charset="0"/>
+                                </a:rPr>
+                              </m:ctrlPr>
+                            </m:dPr>
+                            <m:e>
+                              <m:r>
+                                <a:rPr lang="en-US" i="1">
+                                  <a:solidFill>
+                                    <a:schemeClr val="tx1"/>
+                                  </a:solidFill>
+                                  <a:latin typeface="Cambria Math" panose="02040503050406030204" pitchFamily="18" charset="0"/>
+                                </a:rPr>
+                                <m:t>𝜃</m:t>
+                              </m:r>
+                            </m:e>
+                          </m:d>
+                        </m:e>
+                      </m:func>
+                      <m:r>
+                        <a:rPr lang="en-US" b="0" i="1" smtClean="0">
+                          <a:solidFill>
+                            <a:schemeClr val="tx1"/>
+                          </a:solidFill>
+                          <a:latin typeface="Cambria Math" panose="02040503050406030204" pitchFamily="18" charset="0"/>
+                        </a:rPr>
+                        <m:t>+</m:t>
+                      </m:r>
+                      <m:r>
+                        <a:rPr lang="en-US" b="0" i="1" smtClean="0">
+                          <a:solidFill>
+                            <a:schemeClr val="tx1"/>
+                          </a:solidFill>
+                          <a:latin typeface="Cambria Math" panose="02040503050406030204" pitchFamily="18" charset="0"/>
+                        </a:rPr>
+                        <m:t>𝑓</m:t>
+                      </m:r>
+                      <m:d>
+                        <m:dPr>
+                          <m:ctrlPr>
+                            <a:rPr lang="en-US" b="0" i="1" smtClean="0">
+                              <a:solidFill>
+                                <a:schemeClr val="tx1"/>
+                              </a:solidFill>
+                              <a:latin typeface="Cambria Math" panose="02040503050406030204" pitchFamily="18" charset="0"/>
+                            </a:rPr>
+                          </m:ctrlPr>
+                        </m:dPr>
+                        <m:e>
+                          <m:r>
+                            <a:rPr lang="en-US" b="0" i="1" smtClean="0">
+                              <a:solidFill>
+                                <a:schemeClr val="tx1"/>
+                              </a:solidFill>
+                              <a:latin typeface="Cambria Math" panose="02040503050406030204" pitchFamily="18" charset="0"/>
+                            </a:rPr>
+                            <m:t>𝑥</m:t>
+                          </m:r>
+                          <m:r>
+                            <a:rPr lang="en-US" b="0" i="1" smtClean="0">
+                              <a:solidFill>
+                                <a:schemeClr val="tx1"/>
+                              </a:solidFill>
+                              <a:latin typeface="Cambria Math" panose="02040503050406030204" pitchFamily="18" charset="0"/>
+                            </a:rPr>
+                            <m:t>, </m:t>
+                          </m:r>
+                          <m:r>
+                            <a:rPr lang="en-US" b="0" i="1" smtClean="0">
+                              <a:solidFill>
+                                <a:schemeClr val="tx1"/>
+                              </a:solidFill>
+                              <a:latin typeface="Cambria Math" panose="02040503050406030204" pitchFamily="18" charset="0"/>
+                            </a:rPr>
+                            <m:t>𝜃</m:t>
+                          </m:r>
+                        </m:e>
+                      </m:d>
+                    </m:oMath>
+                    <m:oMath xmlns:m="http://schemas.openxmlformats.org/officeDocument/2006/math">
+                      <m:func>
+                        <m:funcPr>
+                          <m:ctrlPr>
+                            <a:rPr lang="en-US" b="0" i="1" smtClean="0">
+                              <a:solidFill>
+                                <a:schemeClr val="tx1"/>
+                              </a:solidFill>
+                              <a:latin typeface="Cambria Math" panose="02040503050406030204" pitchFamily="18" charset="0"/>
+                            </a:rPr>
+                          </m:ctrlPr>
+                        </m:funcPr>
+                        <m:fName>
+                          <m:r>
+                            <m:rPr>
+                              <m:sty m:val="p"/>
+                            </m:rPr>
+                            <a:rPr lang="en-US" b="0" i="0" smtClean="0">
+                              <a:solidFill>
+                                <a:schemeClr val="tx1"/>
+                              </a:solidFill>
+                              <a:latin typeface="Cambria Math" panose="02040503050406030204" pitchFamily="18" charset="0"/>
+                            </a:rPr>
+                            <m:t>log</m:t>
+                          </m:r>
+                        </m:fName>
+                        <m:e>
+                          <m:r>
+                            <a:rPr lang="en-US" b="0" i="1" smtClean="0">
+                              <a:solidFill>
+                                <a:schemeClr val="tx1"/>
+                              </a:solidFill>
+                              <a:latin typeface="Cambria Math" panose="02040503050406030204" pitchFamily="18" charset="0"/>
+                            </a:rPr>
+                            <m:t>𝑢</m:t>
+                          </m:r>
+                          <m:d>
+                            <m:dPr>
+                              <m:ctrlPr>
+                                <a:rPr lang="en-US" b="0" i="1" smtClean="0">
+                                  <a:solidFill>
+                                    <a:schemeClr val="tx1"/>
+                                  </a:solidFill>
+                                  <a:latin typeface="Cambria Math" panose="02040503050406030204" pitchFamily="18" charset="0"/>
+                                </a:rPr>
+                              </m:ctrlPr>
+                            </m:dPr>
+                            <m:e>
+                              <m:r>
+                                <a:rPr lang="en-US" b="0" i="1" smtClean="0">
+                                  <a:solidFill>
+                                    <a:schemeClr val="tx1"/>
+                                  </a:solidFill>
+                                  <a:latin typeface="Cambria Math" panose="02040503050406030204" pitchFamily="18" charset="0"/>
+                                </a:rPr>
+                                <m:t>𝑥</m:t>
+                              </m:r>
+                            </m:e>
+                            <m:e>
+                              <m:r>
+                                <a:rPr lang="en-US" b="0" i="1" smtClean="0">
+                                  <a:solidFill>
+                                    <a:schemeClr val="tx1"/>
+                                  </a:solidFill>
+                                  <a:latin typeface="Cambria Math" panose="02040503050406030204" pitchFamily="18" charset="0"/>
+                                </a:rPr>
+                                <m:t>𝜃</m:t>
+                              </m:r>
+                            </m:e>
+                          </m:d>
+                          <m:r>
+                            <m:rPr>
+                              <m:aln/>
+                            </m:rPr>
+                            <a:rPr lang="en-US" b="0" i="1" smtClean="0">
+                              <a:solidFill>
+                                <a:schemeClr val="tx1"/>
+                              </a:solidFill>
+                              <a:latin typeface="Cambria Math" panose="02040503050406030204" pitchFamily="18" charset="0"/>
+                            </a:rPr>
+                            <m:t>=</m:t>
+                          </m:r>
+                          <m:func>
+                            <m:funcPr>
+                              <m:ctrlPr>
+                                <a:rPr lang="en-US" b="0" i="1" smtClean="0">
+                                  <a:solidFill>
+                                    <a:schemeClr val="tx1"/>
+                                  </a:solidFill>
+                                  <a:latin typeface="Cambria Math" panose="02040503050406030204" pitchFamily="18" charset="0"/>
+                                </a:rPr>
+                              </m:ctrlPr>
+                            </m:funcPr>
+                            <m:fName>
+                              <m:r>
+                                <m:rPr>
+                                  <m:sty m:val="p"/>
+                                </m:rPr>
+                                <a:rPr lang="en-US" b="0" i="0" smtClean="0">
+                                  <a:solidFill>
+                                    <a:schemeClr val="tx1"/>
+                                  </a:solidFill>
+                                  <a:latin typeface="Cambria Math" panose="02040503050406030204" pitchFamily="18" charset="0"/>
+                                </a:rPr>
+                                <m:t>log</m:t>
+                              </m:r>
+                            </m:fName>
+                            <m:e>
+                              <m:r>
+                                <a:rPr lang="en-US" b="0" i="1" smtClean="0">
+                                  <a:solidFill>
+                                    <a:schemeClr val="tx1"/>
+                                  </a:solidFill>
+                                  <a:latin typeface="Cambria Math" panose="02040503050406030204" pitchFamily="18" charset="0"/>
+                                </a:rPr>
+                                <m:t>𝑢</m:t>
+                              </m:r>
+                              <m:d>
+                                <m:dPr>
+                                  <m:ctrlPr>
+                                    <a:rPr lang="en-US" b="0" i="1" smtClean="0">
+                                      <a:solidFill>
+                                        <a:schemeClr val="tx1"/>
+                                      </a:solidFill>
+                                      <a:latin typeface="Cambria Math" panose="02040503050406030204" pitchFamily="18" charset="0"/>
+                                    </a:rPr>
+                                  </m:ctrlPr>
+                                </m:dPr>
+                                <m:e>
+                                  <m:r>
+                                    <a:rPr lang="en-US" b="0" i="1" smtClean="0">
+                                      <a:solidFill>
+                                        <a:schemeClr val="tx1"/>
+                                      </a:solidFill>
+                                      <a:latin typeface="Cambria Math" panose="02040503050406030204" pitchFamily="18" charset="0"/>
+                                    </a:rPr>
+                                    <m:t>𝑥</m:t>
+                                  </m:r>
+                                  <m:r>
+                                    <a:rPr lang="en-US" b="0" i="1" smtClean="0">
+                                      <a:solidFill>
+                                        <a:schemeClr val="tx1"/>
+                                      </a:solidFill>
+                                      <a:latin typeface="Cambria Math" panose="02040503050406030204" pitchFamily="18" charset="0"/>
+                                    </a:rPr>
+                                    <m:t>,</m:t>
+                                  </m:r>
+                                  <m:r>
+                                    <a:rPr lang="en-US" b="0" i="1" smtClean="0">
+                                      <a:solidFill>
+                                        <a:schemeClr val="tx1"/>
+                                      </a:solidFill>
+                                      <a:latin typeface="Cambria Math" panose="02040503050406030204" pitchFamily="18" charset="0"/>
+                                    </a:rPr>
+                                    <m:t>𝜃</m:t>
+                                  </m:r>
+                                </m:e>
+                              </m:d>
+                              <m:r>
+                                <a:rPr lang="en-US" b="0" i="1" smtClean="0">
+                                  <a:solidFill>
+                                    <a:schemeClr val="tx1"/>
+                                  </a:solidFill>
+                                  <a:latin typeface="Cambria Math" panose="02040503050406030204" pitchFamily="18" charset="0"/>
+                                </a:rPr>
+                                <m:t>−</m:t>
+                              </m:r>
+                              <m:func>
+                                <m:funcPr>
+                                  <m:ctrlPr>
+                                    <a:rPr lang="en-US" b="0" i="1" smtClean="0">
+                                      <a:solidFill>
+                                        <a:schemeClr val="tx1"/>
+                                      </a:solidFill>
+                                      <a:latin typeface="Cambria Math" panose="02040503050406030204" pitchFamily="18" charset="0"/>
+                                    </a:rPr>
+                                  </m:ctrlPr>
+                                </m:funcPr>
+                                <m:fName>
+                                  <m:r>
+                                    <m:rPr>
+                                      <m:sty m:val="p"/>
+                                    </m:rPr>
+                                    <a:rPr lang="en-US" b="0" i="0" smtClean="0">
+                                      <a:solidFill>
+                                        <a:schemeClr val="tx1"/>
+                                      </a:solidFill>
+                                      <a:latin typeface="Cambria Math" panose="02040503050406030204" pitchFamily="18" charset="0"/>
+                                    </a:rPr>
+                                    <m:t>log</m:t>
+                                  </m:r>
+                                </m:fName>
+                                <m:e>
+                                  <m:r>
+                                    <a:rPr lang="en-US" b="0" i="1" smtClean="0">
+                                      <a:solidFill>
+                                        <a:schemeClr val="tx1"/>
+                                      </a:solidFill>
+                                      <a:latin typeface="Cambria Math" panose="02040503050406030204" pitchFamily="18" charset="0"/>
+                                    </a:rPr>
+                                    <m:t>𝜋</m:t>
+                                  </m:r>
+                                  <m:r>
+                                    <a:rPr lang="en-US" b="0" i="1" smtClean="0">
+                                      <a:solidFill>
+                                        <a:schemeClr val="tx1"/>
+                                      </a:solidFill>
+                                      <a:latin typeface="Cambria Math" panose="02040503050406030204" pitchFamily="18" charset="0"/>
+                                    </a:rPr>
+                                    <m:t>(</m:t>
+                                  </m:r>
+                                  <m:r>
+                                    <a:rPr lang="en-US" b="0" i="1" smtClean="0">
+                                      <a:solidFill>
+                                        <a:schemeClr val="tx1"/>
+                                      </a:solidFill>
+                                      <a:latin typeface="Cambria Math" panose="02040503050406030204" pitchFamily="18" charset="0"/>
+                                    </a:rPr>
+                                    <m:t>𝜃</m:t>
+                                  </m:r>
+                                  <m:r>
+                                    <a:rPr lang="en-US" b="0" i="1" smtClean="0">
+                                      <a:solidFill>
+                                        <a:schemeClr val="tx1"/>
+                                      </a:solidFill>
+                                      <a:latin typeface="Cambria Math" panose="02040503050406030204" pitchFamily="18" charset="0"/>
+                                    </a:rPr>
+                                    <m:t>)</m:t>
+                                  </m:r>
+                                </m:e>
+                              </m:func>
+                            </m:e>
+                          </m:func>
+                          <m:r>
+                            <a:rPr lang="en-US" b="0" i="1" smtClean="0">
+                              <a:solidFill>
+                                <a:schemeClr val="tx1"/>
+                              </a:solidFill>
+                              <a:latin typeface="Cambria Math" panose="02040503050406030204" pitchFamily="18" charset="0"/>
+                            </a:rPr>
+                            <m:t> </m:t>
+                          </m:r>
+                        </m:e>
+                      </m:func>
+                    </m:oMath>
+                  </m:oMathPara>
+                </a14:m>
+                <a:endParaRPr lang="en-US" b="0" i="1" dirty="0">
+                  <a:solidFill>
+                    <a:schemeClr val="tx1"/>
+                  </a:solidFill>
+                  <a:latin typeface="Cambria Math" panose="02040503050406030204" pitchFamily="18" charset="0"/>
+                </a:endParaRPr>
+              </a:p>
+              <a:p>
+                <a:pPr marL="0" indent="0">
+                  <a:buNone/>
+                </a:pPr>
+                <a:r>
+                  <a:rPr lang="en-US" sz="2000" dirty="0">
+                    <a:solidFill>
+                      <a:srgbClr val="0033CC"/>
+                    </a:solidFill>
+                    <a:latin typeface="+mn-lt"/>
+                  </a:rPr>
+                  <a:t>* Which one?</a:t>
+                </a:r>
+              </a:p>
+            </p:txBody>
+          </p:sp>
+        </mc:Choice>
+        <mc:Fallback>
+          <p:sp>
+            <p:nvSpPr>
+              <p:cNvPr id="8" name="Content Placeholder 7">
+                <a:extLst>
+                  <a:ext uri="{FF2B5EF4-FFF2-40B4-BE49-F238E27FC236}">
+                    <a16:creationId xmlns:a16="http://schemas.microsoft.com/office/drawing/2014/main" id="{67A66908-D4A5-D232-6893-666E46FDB5E0}"/>
+                  </a:ext>
+                </a:extLst>
+              </p:cNvPr>
+              <p:cNvSpPr>
+                <a:spLocks noGrp="1" noRot="1" noChangeAspect="1" noMove="1" noResize="1" noEditPoints="1" noAdjustHandles="1" noChangeArrowheads="1" noChangeShapeType="1" noTextEdit="1"/>
+              </p:cNvSpPr>
+              <p:nvPr>
+                <p:ph idx="1"/>
+              </p:nvPr>
+            </p:nvSpPr>
+            <p:spPr>
+              <a:xfrm>
+                <a:off x="711200" y="1295400"/>
+                <a:ext cx="7899400" cy="4819650"/>
+              </a:xfrm>
+              <a:blipFill>
+                <a:blip r:embed="rId2"/>
+                <a:stretch>
+                  <a:fillRect l="-1284" t="-1316" r="-1766" b="-2368"/>
+                </a:stretch>
+              </a:blipFill>
+            </p:spPr>
+            <p:txBody>
+              <a:bodyPr/>
+              <a:lstStyle/>
+              <a:p>
+                <a:r>
+                  <a:rPr lang="en-US">
+                    <a:noFill/>
+                  </a:rPr>
+                  <a:t> </a:t>
+                </a:r>
+              </a:p>
+            </p:txBody>
+          </p:sp>
+        </mc:Fallback>
+      </mc:AlternateContent>
+    </p:spTree>
+    <p:extLst>
+      <p:ext uri="{BB962C8B-B14F-4D97-AF65-F5344CB8AC3E}">
+        <p14:creationId xmlns:p14="http://schemas.microsoft.com/office/powerpoint/2010/main" val="2034311652"/>
+      </p:ext>
+    </p:extLst>
+  </p:cSld>
+  <p:clrMapOvr>
+    <a:masterClrMapping/>
+  </p:clrMapOvr>
+  <mc:AlternateContent xmlns:mc="http://schemas.openxmlformats.org/markup-compatibility/2006">
+    <mc:Choice xmlns:p14="http://schemas.microsoft.com/office/powerpoint/2010/main" Requires="p14">
+      <p:transition spd="med" p14:dur="700">
+        <p:fade/>
+      </p:transition>
+    </mc:Choice>
+    <mc:Fallback>
+      <p:transition spd="med">
+        <p:fade/>
+      </p:transition>
+    </mc:Fallback>
+  </mc:AlternateContent>
+  <p:timing>
+    <p:tnLst>
+      <p:par>
+        <p:cTn id="1" dur="indefinite" restart="never" nodeType="tmRoot">
+          <p:childTnLst>
+            <p:seq concurrent="1" nextAc="seek">
+              <p:cTn id="2" dur="indefinite" nodeType="mainSeq">
+                <p:childTnLst>
+                  <p:par>
+                    <p:cTn id="3" fill="hold">
+                      <p:stCondLst>
+                        <p:cond delay="indefinite"/>
+                      </p:stCondLst>
+                      <p:childTnLst>
+                        <p:par>
+                          <p:cTn id="4" fill="hold">
+                            <p:stCondLst>
+                              <p:cond delay="0"/>
+                            </p:stCondLst>
+                            <p:childTnLst>
+                              <p:par>
+                                <p:cTn id="5" presetID="10" presetClass="entr" presetSubtype="0" fill="hold" nodeType="clickEffect">
+                                  <p:stCondLst>
+                                    <p:cond delay="0"/>
+                                  </p:stCondLst>
+                                  <p:childTnLst>
+                                    <p:set>
+                                      <p:cBhvr>
+                                        <p:cTn id="6" dur="1" fill="hold">
+                                          <p:stCondLst>
+                                            <p:cond delay="0"/>
+                                          </p:stCondLst>
+                                        </p:cTn>
+                                        <p:tgtEl>
+                                          <p:spTgt spid="8">
+                                            <p:txEl>
+                                              <p:pRg st="3" end="3"/>
+                                            </p:txEl>
+                                          </p:spTgt>
+                                        </p:tgtEl>
+                                        <p:attrNameLst>
+                                          <p:attrName>style.visibility</p:attrName>
+                                        </p:attrNameLst>
+                                      </p:cBhvr>
+                                      <p:to>
+                                        <p:strVal val="visible"/>
+                                      </p:to>
+                                    </p:set>
+                                    <p:animEffect transition="in" filter="fade">
+                                      <p:cBhvr>
+                                        <p:cTn id="7" dur="500"/>
+                                        <p:tgtEl>
+                                          <p:spTgt spid="8">
+                                            <p:txEl>
+                                              <p:pRg st="3" end="3"/>
+                                            </p:txEl>
+                                          </p:spTgt>
+                                        </p:tgtEl>
+                                      </p:cBhvr>
+                                    </p:animEffect>
+                                  </p:childTnLst>
+                                </p:cTn>
+                              </p:par>
+                              <p:par>
+                                <p:cTn id="8" presetID="10" presetClass="entr" presetSubtype="0" fill="hold" nodeType="withEffect">
+                                  <p:stCondLst>
+                                    <p:cond delay="0"/>
+                                  </p:stCondLst>
+                                  <p:childTnLst>
+                                    <p:set>
+                                      <p:cBhvr>
+                                        <p:cTn id="9" dur="1" fill="hold">
+                                          <p:stCondLst>
+                                            <p:cond delay="0"/>
+                                          </p:stCondLst>
+                                        </p:cTn>
+                                        <p:tgtEl>
+                                          <p:spTgt spid="8">
+                                            <p:txEl>
+                                              <p:pRg st="4" end="4"/>
+                                            </p:txEl>
+                                          </p:spTgt>
+                                        </p:tgtEl>
+                                        <p:attrNameLst>
+                                          <p:attrName>style.visibility</p:attrName>
+                                        </p:attrNameLst>
+                                      </p:cBhvr>
+                                      <p:to>
+                                        <p:strVal val="visible"/>
+                                      </p:to>
+                                    </p:set>
+                                    <p:animEffect transition="in" filter="fade">
+                                      <p:cBhvr>
+                                        <p:cTn id="10" dur="500"/>
+                                        <p:tgtEl>
+                                          <p:spTgt spid="8">
+                                            <p:txEl>
+                                              <p:pRg st="4" end="4"/>
+                                            </p:txEl>
+                                          </p:spTgt>
+                                        </p:tgtEl>
+                                      </p:cBhvr>
+                                    </p:animEffect>
+                                  </p:childTnLst>
+                                </p:cTn>
+                              </p:par>
+                              <p:par>
+                                <p:cTn id="11" presetID="10" presetClass="entr" presetSubtype="0" fill="hold" nodeType="withEffect">
+                                  <p:stCondLst>
+                                    <p:cond delay="0"/>
+                                  </p:stCondLst>
+                                  <p:childTnLst>
+                                    <p:set>
+                                      <p:cBhvr>
+                                        <p:cTn id="12" dur="1" fill="hold">
+                                          <p:stCondLst>
+                                            <p:cond delay="0"/>
+                                          </p:stCondLst>
+                                        </p:cTn>
+                                        <p:tgtEl>
+                                          <p:spTgt spid="8">
+                                            <p:txEl>
+                                              <p:pRg st="7" end="7"/>
+                                            </p:txEl>
+                                          </p:spTgt>
+                                        </p:tgtEl>
+                                        <p:attrNameLst>
+                                          <p:attrName>style.visibility</p:attrName>
+                                        </p:attrNameLst>
+                                      </p:cBhvr>
+                                      <p:to>
+                                        <p:strVal val="visible"/>
+                                      </p:to>
+                                    </p:set>
+                                    <p:animEffect transition="in" filter="fade">
+                                      <p:cBhvr>
+                                        <p:cTn id="13" dur="500"/>
+                                        <p:tgtEl>
+                                          <p:spTgt spid="8">
+                                            <p:txEl>
+                                              <p:pRg st="7" end="7"/>
+                                            </p:txEl>
+                                          </p:spTgt>
+                                        </p:tgtEl>
+                                      </p:cBhvr>
+                                    </p:animEffect>
+                                  </p:childTnLst>
+                                </p:cTn>
+                              </p:par>
+                            </p:childTnLst>
+                          </p:cTn>
+                        </p:par>
+                      </p:childTnLst>
+                    </p:cTn>
+                  </p:par>
+                  <p:par>
+                    <p:cTn id="14" fill="hold">
+                      <p:stCondLst>
+                        <p:cond delay="indefinite"/>
+                      </p:stCondLst>
+                      <p:childTnLst>
+                        <p:par>
+                          <p:cTn id="15" fill="hold">
+                            <p:stCondLst>
+                              <p:cond delay="0"/>
+                            </p:stCondLst>
+                            <p:childTnLst>
+                              <p:par>
+                                <p:cTn id="16" presetID="10" presetClass="entr" presetSubtype="0" fill="hold" nodeType="clickEffect">
+                                  <p:stCondLst>
+                                    <p:cond delay="0"/>
+                                  </p:stCondLst>
+                                  <p:childTnLst>
+                                    <p:set>
+                                      <p:cBhvr>
+                                        <p:cTn id="17" dur="1" fill="hold">
+                                          <p:stCondLst>
+                                            <p:cond delay="0"/>
+                                          </p:stCondLst>
+                                        </p:cTn>
+                                        <p:tgtEl>
+                                          <p:spTgt spid="8">
+                                            <p:txEl>
+                                              <p:pRg st="5" end="5"/>
+                                            </p:txEl>
+                                          </p:spTgt>
+                                        </p:tgtEl>
+                                        <p:attrNameLst>
+                                          <p:attrName>style.visibility</p:attrName>
+                                        </p:attrNameLst>
+                                      </p:cBhvr>
+                                      <p:to>
+                                        <p:strVal val="visible"/>
+                                      </p:to>
+                                    </p:set>
+                                    <p:animEffect transition="in" filter="fade">
+                                      <p:cBhvr>
+                                        <p:cTn id="18" dur="500"/>
+                                        <p:tgtEl>
+                                          <p:spTgt spid="8">
+                                            <p:txEl>
+                                              <p:pRg st="5" end="5"/>
+                                            </p:txEl>
+                                          </p:spTgt>
+                                        </p:tgtEl>
+                                      </p:cBhvr>
+                                    </p:animEffect>
+                                  </p:childTnLst>
+                                </p:cTn>
+                              </p:par>
+                              <p:par>
+                                <p:cTn id="19" presetID="10" presetClass="entr" presetSubtype="0" fill="hold" nodeType="withEffect">
+                                  <p:stCondLst>
+                                    <p:cond delay="0"/>
+                                  </p:stCondLst>
+                                  <p:childTnLst>
+                                    <p:set>
+                                      <p:cBhvr>
+                                        <p:cTn id="20" dur="1" fill="hold">
+                                          <p:stCondLst>
+                                            <p:cond delay="0"/>
+                                          </p:stCondLst>
+                                        </p:cTn>
+                                        <p:tgtEl>
+                                          <p:spTgt spid="8">
+                                            <p:txEl>
+                                              <p:pRg st="6" end="6"/>
+                                            </p:txEl>
+                                          </p:spTgt>
+                                        </p:tgtEl>
+                                        <p:attrNameLst>
+                                          <p:attrName>style.visibility</p:attrName>
+                                        </p:attrNameLst>
+                                      </p:cBhvr>
+                                      <p:to>
+                                        <p:strVal val="visible"/>
+                                      </p:to>
+                                    </p:set>
+                                    <p:animEffect transition="in" filter="fade">
+                                      <p:cBhvr>
+                                        <p:cTn id="21" dur="500"/>
+                                        <p:tgtEl>
+                                          <p:spTgt spid="8">
+                                            <p:txEl>
+                                              <p:pRg st="6" end="6"/>
+                                            </p:txEl>
+                                          </p:spTgt>
+                                        </p:tgtEl>
+                                      </p:cBhvr>
+                                    </p:animEffect>
+                                  </p:childTnLst>
+                                </p:cTn>
+                              </p:par>
+                            </p:childTnLst>
+                          </p:cTn>
+                        </p:par>
+                      </p:childTnLst>
+                    </p:cTn>
+                  </p:par>
+                </p:childTnLst>
+              </p:cTn>
+              <p:prevCondLst>
+                <p:cond evt="onPrev" delay="0">
+                  <p:tgtEl>
+                    <p:sldTgt/>
+                  </p:tgtEl>
+                </p:cond>
+              </p:prevCondLst>
+              <p:nextCondLst>
+                <p:cond evt="onNext" delay="0">
+                  <p:tgtEl>
+                    <p:sldTgt/>
+                  </p:tgtEl>
+                </p:cond>
+              </p:nextCondLst>
+            </p:seq>
+          </p:childTnLst>
+        </p:cTn>
+      </p:par>
+    </p:tnLst>
+  </p:timing>
+</p:sld>
+</file>
+
+<file path=ppt/slides/slide26.xml><?xml version="1.0" encoding="utf-8"?>
 <p:sld xmlns:a="http://schemas.openxmlformats.org/drawingml/2006/main" xmlns:r="http://schemas.openxmlformats.org/officeDocument/2006/relationships" xmlns:p="http://schemas.openxmlformats.org/presentationml/2006/main">
   <p:cSld>
     <p:spTree>

</xml_diff>